<commit_message>
chore: save latest pitch deck artifacts and test scripts
</commit_message>
<xml_diff>
--- a/CompliScan_AI_SIH2026_PitchDeck.pptx
+++ b/CompliScan_AI_SIH2026_PitchDeck.pptx
@@ -5,19 +5,19 @@
     <p:sldMasterId id="2147483648" r:id="rId1"/>
   </p:sldMasterIdLst>
   <p:sldIdLst>
-    <p:sldId id="256" r:id="rId7"/>
-    <p:sldId id="257" r:id="rId8"/>
-    <p:sldId id="258" r:id="rId9"/>
-    <p:sldId id="259" r:id="rId10"/>
-    <p:sldId id="260" r:id="rId11"/>
-    <p:sldId id="261" r:id="rId12"/>
-    <p:sldId id="262" r:id="rId13"/>
-    <p:sldId id="263" r:id="rId14"/>
-    <p:sldId id="264" r:id="rId15"/>
-    <p:sldId id="265" r:id="rId16"/>
-    <p:sldId id="266" r:id="rId17"/>
+    <p:sldId id="256" r:id="rId2"/>
+    <p:sldId id="257" r:id="rId3"/>
+    <p:sldId id="258" r:id="rId4"/>
+    <p:sldId id="259" r:id="rId5"/>
+    <p:sldId id="260" r:id="rId6"/>
+    <p:sldId id="261" r:id="rId7"/>
+    <p:sldId id="262" r:id="rId8"/>
+    <p:sldId id="263" r:id="rId9"/>
+    <p:sldId id="264" r:id="rId10"/>
+    <p:sldId id="265" r:id="rId11"/>
+    <p:sldId id="266" r:id="rId12"/>
   </p:sldIdLst>
-  <p:sldSz cx="12191695" cy="6858000" type="screen4x3"/>
+  <p:sldSz cx="12192000" cy="6858000"/>
   <p:notesSz cx="6858000" cy="9144000"/>
   <p:defaultTextStyle>
     <a:defPPr>
@@ -114,6 +114,22 @@
       </a:defRPr>
     </a:lvl9pPr>
   </p:defaultTextStyle>
+  <p:extLst>
+    <p:ext uri="{EFAFB233-063F-42B5-8137-9DF3F51BA10A}">
+      <p15:sldGuideLst xmlns:p15="http://schemas.microsoft.com/office/powerpoint/2012/main">
+        <p15:guide id="1" orient="horz" pos="2160">
+          <p15:clr>
+            <a:srgbClr val="A4A3A4"/>
+          </p15:clr>
+        </p15:guide>
+        <p15:guide id="2" pos="2880">
+          <p15:clr>
+            <a:srgbClr val="A4A3A4"/>
+          </p15:clr>
+        </p15:guide>
+      </p15:sldGuideLst>
+    </p:ext>
+  </p:extLst>
 </p:presentation>
 </file>
 
@@ -155,10 +171,9 @@
           <a:lstStyle/>
           <a:p>
             <a:r>
-              <a:rPr lang="en-US" smtClean="0"/>
+              <a:rPr lang="en-US"/>
               <a:t>Click to edit Master title style</a:t>
             </a:r>
-            <a:endParaRPr lang="en-US"/>
           </a:p>
         </p:txBody>
       </p:sp>
@@ -274,10 +289,9 @@
           </a:lstStyle>
           <a:p>
             <a:r>
-              <a:rPr lang="en-US" smtClean="0"/>
+              <a:rPr lang="en-US"/>
               <a:t>Click to edit Master subtitle style</a:t>
             </a:r>
-            <a:endParaRPr lang="en-US"/>
           </a:p>
         </p:txBody>
       </p:sp>
@@ -298,7 +312,7 @@
           <a:p>
             <a:fld id="{5BCAD085-E8A6-8845-BD4E-CB4CCA059FC4}" type="datetimeFigureOut">
               <a:rPr lang="en-US" smtClean="0"/>
-              <a:t>1/27/13</a:t>
+              <a:t>9/12/2026</a:t>
             </a:fld>
             <a:endParaRPr lang="en-US"/>
           </a:p>
@@ -392,10 +406,9 @@
           <a:lstStyle/>
           <a:p>
             <a:r>
-              <a:rPr lang="en-US" smtClean="0"/>
+              <a:rPr lang="en-US"/>
               <a:t>Click to edit Master title style</a:t>
             </a:r>
-            <a:endParaRPr lang="en-US"/>
           </a:p>
         </p:txBody>
       </p:sp>
@@ -416,38 +429,37 @@
           <a:p>
             <a:pPr lvl="0"/>
             <a:r>
-              <a:rPr lang="en-US" smtClean="0"/>
+              <a:rPr lang="en-US"/>
               <a:t>Click to edit Master text styles</a:t>
             </a:r>
           </a:p>
           <a:p>
             <a:pPr lvl="1"/>
             <a:r>
-              <a:rPr lang="en-US" smtClean="0"/>
+              <a:rPr lang="en-US"/>
               <a:t>Second level</a:t>
             </a:r>
           </a:p>
           <a:p>
             <a:pPr lvl="2"/>
             <a:r>
-              <a:rPr lang="en-US" smtClean="0"/>
+              <a:rPr lang="en-US"/>
               <a:t>Third level</a:t>
             </a:r>
           </a:p>
           <a:p>
             <a:pPr lvl="3"/>
             <a:r>
-              <a:rPr lang="en-US" smtClean="0"/>
+              <a:rPr lang="en-US"/>
               <a:t>Fourth level</a:t>
             </a:r>
           </a:p>
           <a:p>
             <a:pPr lvl="4"/>
             <a:r>
-              <a:rPr lang="en-US" smtClean="0"/>
+              <a:rPr lang="en-US"/>
               <a:t>Fifth level</a:t>
             </a:r>
-            <a:endParaRPr lang="en-US"/>
           </a:p>
         </p:txBody>
       </p:sp>
@@ -468,7 +480,7 @@
           <a:p>
             <a:fld id="{5BCAD085-E8A6-8845-BD4E-CB4CCA059FC4}" type="datetimeFigureOut">
               <a:rPr lang="en-US" smtClean="0"/>
-              <a:t>1/27/13</a:t>
+              <a:t>9/12/2026</a:t>
             </a:fld>
             <a:endParaRPr lang="en-US"/>
           </a:p>
@@ -567,10 +579,9 @@
           <a:lstStyle/>
           <a:p>
             <a:r>
-              <a:rPr lang="en-US" smtClean="0"/>
+              <a:rPr lang="en-US"/>
               <a:t>Click to edit Master title style</a:t>
             </a:r>
-            <a:endParaRPr lang="en-US"/>
           </a:p>
         </p:txBody>
       </p:sp>
@@ -596,38 +607,37 @@
           <a:p>
             <a:pPr lvl="0"/>
             <a:r>
-              <a:rPr lang="en-US" smtClean="0"/>
+              <a:rPr lang="en-US"/>
               <a:t>Click to edit Master text styles</a:t>
             </a:r>
           </a:p>
           <a:p>
             <a:pPr lvl="1"/>
             <a:r>
-              <a:rPr lang="en-US" smtClean="0"/>
+              <a:rPr lang="en-US"/>
               <a:t>Second level</a:t>
             </a:r>
           </a:p>
           <a:p>
             <a:pPr lvl="2"/>
             <a:r>
-              <a:rPr lang="en-US" smtClean="0"/>
+              <a:rPr lang="en-US"/>
               <a:t>Third level</a:t>
             </a:r>
           </a:p>
           <a:p>
             <a:pPr lvl="3"/>
             <a:r>
-              <a:rPr lang="en-US" smtClean="0"/>
+              <a:rPr lang="en-US"/>
               <a:t>Fourth level</a:t>
             </a:r>
           </a:p>
           <a:p>
             <a:pPr lvl="4"/>
             <a:r>
-              <a:rPr lang="en-US" smtClean="0"/>
+              <a:rPr lang="en-US"/>
               <a:t>Fifth level</a:t>
             </a:r>
-            <a:endParaRPr lang="en-US"/>
           </a:p>
         </p:txBody>
       </p:sp>
@@ -648,7 +658,7 @@
           <a:p>
             <a:fld id="{5BCAD085-E8A6-8845-BD4E-CB4CCA059FC4}" type="datetimeFigureOut">
               <a:rPr lang="en-US" smtClean="0"/>
-              <a:t>1/27/13</a:t>
+              <a:t>9/12/2026</a:t>
             </a:fld>
             <a:endParaRPr lang="en-US"/>
           </a:p>
@@ -742,10 +752,9 @@
           <a:lstStyle/>
           <a:p>
             <a:r>
-              <a:rPr lang="en-US" smtClean="0"/>
+              <a:rPr lang="en-US"/>
               <a:t>Click to edit Master title style</a:t>
             </a:r>
-            <a:endParaRPr lang="en-US"/>
           </a:p>
         </p:txBody>
       </p:sp>
@@ -766,38 +775,37 @@
           <a:p>
             <a:pPr lvl="0"/>
             <a:r>
-              <a:rPr lang="en-US" smtClean="0"/>
+              <a:rPr lang="en-US"/>
               <a:t>Click to edit Master text styles</a:t>
             </a:r>
           </a:p>
           <a:p>
             <a:pPr lvl="1"/>
             <a:r>
-              <a:rPr lang="en-US" smtClean="0"/>
+              <a:rPr lang="en-US"/>
               <a:t>Second level</a:t>
             </a:r>
           </a:p>
           <a:p>
             <a:pPr lvl="2"/>
             <a:r>
-              <a:rPr lang="en-US" smtClean="0"/>
+              <a:rPr lang="en-US"/>
               <a:t>Third level</a:t>
             </a:r>
           </a:p>
           <a:p>
             <a:pPr lvl="3"/>
             <a:r>
-              <a:rPr lang="en-US" smtClean="0"/>
+              <a:rPr lang="en-US"/>
               <a:t>Fourth level</a:t>
             </a:r>
           </a:p>
           <a:p>
             <a:pPr lvl="4"/>
             <a:r>
-              <a:rPr lang="en-US" smtClean="0"/>
+              <a:rPr lang="en-US"/>
               <a:t>Fifth level</a:t>
             </a:r>
-            <a:endParaRPr lang="en-US"/>
           </a:p>
         </p:txBody>
       </p:sp>
@@ -818,7 +826,7 @@
           <a:p>
             <a:fld id="{5BCAD085-E8A6-8845-BD4E-CB4CCA059FC4}" type="datetimeFigureOut">
               <a:rPr lang="en-US" smtClean="0"/>
-              <a:t>1/27/13</a:t>
+              <a:t>9/12/2026</a:t>
             </a:fld>
             <a:endParaRPr lang="en-US"/>
           </a:p>
@@ -921,10 +929,9 @@
           </a:lstStyle>
           <a:p>
             <a:r>
-              <a:rPr lang="en-US" smtClean="0"/>
+              <a:rPr lang="en-US"/>
               <a:t>Click to edit Master title style</a:t>
             </a:r>
-            <a:endParaRPr lang="en-US"/>
           </a:p>
         </p:txBody>
       </p:sp>
@@ -1041,7 +1048,7 @@
           <a:p>
             <a:pPr lvl="0"/>
             <a:r>
-              <a:rPr lang="en-US" smtClean="0"/>
+              <a:rPr lang="en-US"/>
               <a:t>Click to edit Master text styles</a:t>
             </a:r>
           </a:p>
@@ -1064,7 +1071,7 @@
           <a:p>
             <a:fld id="{5BCAD085-E8A6-8845-BD4E-CB4CCA059FC4}" type="datetimeFigureOut">
               <a:rPr lang="en-US" smtClean="0"/>
-              <a:t>1/27/13</a:t>
+              <a:t>9/12/2026</a:t>
             </a:fld>
             <a:endParaRPr lang="en-US"/>
           </a:p>
@@ -1158,10 +1165,9 @@
           <a:lstStyle/>
           <a:p>
             <a:r>
-              <a:rPr lang="en-US" smtClean="0"/>
+              <a:rPr lang="en-US"/>
               <a:t>Click to edit Master title style</a:t>
             </a:r>
-            <a:endParaRPr lang="en-US"/>
           </a:p>
         </p:txBody>
       </p:sp>
@@ -1215,38 +1221,37 @@
           <a:p>
             <a:pPr lvl="0"/>
             <a:r>
-              <a:rPr lang="en-US" smtClean="0"/>
+              <a:rPr lang="en-US"/>
               <a:t>Click to edit Master text styles</a:t>
             </a:r>
           </a:p>
           <a:p>
             <a:pPr lvl="1"/>
             <a:r>
-              <a:rPr lang="en-US" smtClean="0"/>
+              <a:rPr lang="en-US"/>
               <a:t>Second level</a:t>
             </a:r>
           </a:p>
           <a:p>
             <a:pPr lvl="2"/>
             <a:r>
-              <a:rPr lang="en-US" smtClean="0"/>
+              <a:rPr lang="en-US"/>
               <a:t>Third level</a:t>
             </a:r>
           </a:p>
           <a:p>
             <a:pPr lvl="3"/>
             <a:r>
-              <a:rPr lang="en-US" smtClean="0"/>
+              <a:rPr lang="en-US"/>
               <a:t>Fourth level</a:t>
             </a:r>
           </a:p>
           <a:p>
             <a:pPr lvl="4"/>
             <a:r>
-              <a:rPr lang="en-US" smtClean="0"/>
+              <a:rPr lang="en-US"/>
               <a:t>Fifth level</a:t>
             </a:r>
-            <a:endParaRPr lang="en-US"/>
           </a:p>
         </p:txBody>
       </p:sp>
@@ -1300,38 +1305,37 @@
           <a:p>
             <a:pPr lvl="0"/>
             <a:r>
-              <a:rPr lang="en-US" smtClean="0"/>
+              <a:rPr lang="en-US"/>
               <a:t>Click to edit Master text styles</a:t>
             </a:r>
           </a:p>
           <a:p>
             <a:pPr lvl="1"/>
             <a:r>
-              <a:rPr lang="en-US" smtClean="0"/>
+              <a:rPr lang="en-US"/>
               <a:t>Second level</a:t>
             </a:r>
           </a:p>
           <a:p>
             <a:pPr lvl="2"/>
             <a:r>
-              <a:rPr lang="en-US" smtClean="0"/>
+              <a:rPr lang="en-US"/>
               <a:t>Third level</a:t>
             </a:r>
           </a:p>
           <a:p>
             <a:pPr lvl="3"/>
             <a:r>
-              <a:rPr lang="en-US" smtClean="0"/>
+              <a:rPr lang="en-US"/>
               <a:t>Fourth level</a:t>
             </a:r>
           </a:p>
           <a:p>
             <a:pPr lvl="4"/>
             <a:r>
-              <a:rPr lang="en-US" smtClean="0"/>
+              <a:rPr lang="en-US"/>
               <a:t>Fifth level</a:t>
             </a:r>
-            <a:endParaRPr lang="en-US"/>
           </a:p>
         </p:txBody>
       </p:sp>
@@ -1352,7 +1356,7 @@
           <a:p>
             <a:fld id="{5BCAD085-E8A6-8845-BD4E-CB4CCA059FC4}" type="datetimeFigureOut">
               <a:rPr lang="en-US" smtClean="0"/>
-              <a:t>1/27/13</a:t>
+              <a:t>9/12/2026</a:t>
             </a:fld>
             <a:endParaRPr lang="en-US"/>
           </a:p>
@@ -1450,10 +1454,9 @@
           </a:lstStyle>
           <a:p>
             <a:r>
-              <a:rPr lang="en-US" smtClean="0"/>
+              <a:rPr lang="en-US"/>
               <a:t>Click to edit Master title style</a:t>
             </a:r>
-            <a:endParaRPr lang="en-US"/>
           </a:p>
         </p:txBody>
       </p:sp>
@@ -1516,7 +1519,7 @@
           <a:p>
             <a:pPr lvl="0"/>
             <a:r>
-              <a:rPr lang="en-US" smtClean="0"/>
+              <a:rPr lang="en-US"/>
               <a:t>Click to edit Master text styles</a:t>
             </a:r>
           </a:p>
@@ -1572,38 +1575,37 @@
           <a:p>
             <a:pPr lvl="0"/>
             <a:r>
-              <a:rPr lang="en-US" smtClean="0"/>
+              <a:rPr lang="en-US"/>
               <a:t>Click to edit Master text styles</a:t>
             </a:r>
           </a:p>
           <a:p>
             <a:pPr lvl="1"/>
             <a:r>
-              <a:rPr lang="en-US" smtClean="0"/>
+              <a:rPr lang="en-US"/>
               <a:t>Second level</a:t>
             </a:r>
           </a:p>
           <a:p>
             <a:pPr lvl="2"/>
             <a:r>
-              <a:rPr lang="en-US" smtClean="0"/>
+              <a:rPr lang="en-US"/>
               <a:t>Third level</a:t>
             </a:r>
           </a:p>
           <a:p>
             <a:pPr lvl="3"/>
             <a:r>
-              <a:rPr lang="en-US" smtClean="0"/>
+              <a:rPr lang="en-US"/>
               <a:t>Fourth level</a:t>
             </a:r>
           </a:p>
           <a:p>
             <a:pPr lvl="4"/>
             <a:r>
-              <a:rPr lang="en-US" smtClean="0"/>
+              <a:rPr lang="en-US"/>
               <a:t>Fifth level</a:t>
             </a:r>
-            <a:endParaRPr lang="en-US"/>
           </a:p>
         </p:txBody>
       </p:sp>
@@ -1666,7 +1668,7 @@
           <a:p>
             <a:pPr lvl="0"/>
             <a:r>
-              <a:rPr lang="en-US" smtClean="0"/>
+              <a:rPr lang="en-US"/>
               <a:t>Click to edit Master text styles</a:t>
             </a:r>
           </a:p>
@@ -1722,38 +1724,37 @@
           <a:p>
             <a:pPr lvl="0"/>
             <a:r>
-              <a:rPr lang="en-US" smtClean="0"/>
+              <a:rPr lang="en-US"/>
               <a:t>Click to edit Master text styles</a:t>
             </a:r>
           </a:p>
           <a:p>
             <a:pPr lvl="1"/>
             <a:r>
-              <a:rPr lang="en-US" smtClean="0"/>
+              <a:rPr lang="en-US"/>
               <a:t>Second level</a:t>
             </a:r>
           </a:p>
           <a:p>
             <a:pPr lvl="2"/>
             <a:r>
-              <a:rPr lang="en-US" smtClean="0"/>
+              <a:rPr lang="en-US"/>
               <a:t>Third level</a:t>
             </a:r>
           </a:p>
           <a:p>
             <a:pPr lvl="3"/>
             <a:r>
-              <a:rPr lang="en-US" smtClean="0"/>
+              <a:rPr lang="en-US"/>
               <a:t>Fourth level</a:t>
             </a:r>
           </a:p>
           <a:p>
             <a:pPr lvl="4"/>
             <a:r>
-              <a:rPr lang="en-US" smtClean="0"/>
+              <a:rPr lang="en-US"/>
               <a:t>Fifth level</a:t>
             </a:r>
-            <a:endParaRPr lang="en-US"/>
           </a:p>
         </p:txBody>
       </p:sp>
@@ -1774,7 +1775,7 @@
           <a:p>
             <a:fld id="{5BCAD085-E8A6-8845-BD4E-CB4CCA059FC4}" type="datetimeFigureOut">
               <a:rPr lang="en-US" smtClean="0"/>
-              <a:t>1/27/13</a:t>
+              <a:t>9/12/2026</a:t>
             </a:fld>
             <a:endParaRPr lang="en-US"/>
           </a:p>
@@ -1868,10 +1869,9 @@
           <a:lstStyle/>
           <a:p>
             <a:r>
-              <a:rPr lang="en-US" smtClean="0"/>
+              <a:rPr lang="en-US"/>
               <a:t>Click to edit Master title style</a:t>
             </a:r>
-            <a:endParaRPr lang="en-US"/>
           </a:p>
         </p:txBody>
       </p:sp>
@@ -1892,7 +1892,7 @@
           <a:p>
             <a:fld id="{5BCAD085-E8A6-8845-BD4E-CB4CCA059FC4}" type="datetimeFigureOut">
               <a:rPr lang="en-US" smtClean="0"/>
-              <a:t>1/27/13</a:t>
+              <a:t>9/12/2026</a:t>
             </a:fld>
             <a:endParaRPr lang="en-US"/>
           </a:p>
@@ -1987,7 +1987,7 @@
           <a:p>
             <a:fld id="{5BCAD085-E8A6-8845-BD4E-CB4CCA059FC4}" type="datetimeFigureOut">
               <a:rPr lang="en-US" smtClean="0"/>
-              <a:t>1/27/13</a:t>
+              <a:t>9/12/2026</a:t>
             </a:fld>
             <a:endParaRPr lang="en-US"/>
           </a:p>
@@ -2090,10 +2090,9 @@
           </a:lstStyle>
           <a:p>
             <a:r>
-              <a:rPr lang="en-US" smtClean="0"/>
+              <a:rPr lang="en-US"/>
               <a:t>Click to edit Master title style</a:t>
             </a:r>
-            <a:endParaRPr lang="en-US"/>
           </a:p>
         </p:txBody>
       </p:sp>
@@ -2147,38 +2146,37 @@
           <a:p>
             <a:pPr lvl="0"/>
             <a:r>
-              <a:rPr lang="en-US" smtClean="0"/>
+              <a:rPr lang="en-US"/>
               <a:t>Click to edit Master text styles</a:t>
             </a:r>
           </a:p>
           <a:p>
             <a:pPr lvl="1"/>
             <a:r>
-              <a:rPr lang="en-US" smtClean="0"/>
+              <a:rPr lang="en-US"/>
               <a:t>Second level</a:t>
             </a:r>
           </a:p>
           <a:p>
             <a:pPr lvl="2"/>
             <a:r>
-              <a:rPr lang="en-US" smtClean="0"/>
+              <a:rPr lang="en-US"/>
               <a:t>Third level</a:t>
             </a:r>
           </a:p>
           <a:p>
             <a:pPr lvl="3"/>
             <a:r>
-              <a:rPr lang="en-US" smtClean="0"/>
+              <a:rPr lang="en-US"/>
               <a:t>Fourth level</a:t>
             </a:r>
           </a:p>
           <a:p>
             <a:pPr lvl="4"/>
             <a:r>
-              <a:rPr lang="en-US" smtClean="0"/>
+              <a:rPr lang="en-US"/>
               <a:t>Fifth level</a:t>
             </a:r>
-            <a:endParaRPr lang="en-US"/>
           </a:p>
         </p:txBody>
       </p:sp>
@@ -2241,7 +2239,7 @@
           <a:p>
             <a:pPr lvl="0"/>
             <a:r>
-              <a:rPr lang="en-US" smtClean="0"/>
+              <a:rPr lang="en-US"/>
               <a:t>Click to edit Master text styles</a:t>
             </a:r>
           </a:p>
@@ -2264,7 +2262,7 @@
           <a:p>
             <a:fld id="{5BCAD085-E8A6-8845-BD4E-CB4CCA059FC4}" type="datetimeFigureOut">
               <a:rPr lang="en-US" smtClean="0"/>
-              <a:t>1/27/13</a:t>
+              <a:t>9/12/2026</a:t>
             </a:fld>
             <a:endParaRPr lang="en-US"/>
           </a:p>
@@ -2367,10 +2365,9 @@
           </a:lstStyle>
           <a:p>
             <a:r>
-              <a:rPr lang="en-US" smtClean="0"/>
+              <a:rPr lang="en-US"/>
               <a:t>Click to edit Master title style</a:t>
             </a:r>
-            <a:endParaRPr lang="en-US"/>
           </a:p>
         </p:txBody>
       </p:sp>
@@ -2494,7 +2491,7 @@
           <a:p>
             <a:pPr lvl="0"/>
             <a:r>
-              <a:rPr lang="en-US" smtClean="0"/>
+              <a:rPr lang="en-US"/>
               <a:t>Click to edit Master text styles</a:t>
             </a:r>
           </a:p>
@@ -2517,7 +2514,7 @@
           <a:p>
             <a:fld id="{5BCAD085-E8A6-8845-BD4E-CB4CCA059FC4}" type="datetimeFigureOut">
               <a:rPr lang="en-US" smtClean="0"/>
-              <a:t>1/27/13</a:t>
+              <a:t>9/12/2026</a:t>
             </a:fld>
             <a:endParaRPr lang="en-US"/>
           </a:p>
@@ -2626,10 +2623,9 @@
           <a:lstStyle/>
           <a:p>
             <a:r>
-              <a:rPr lang="en-US" smtClean="0"/>
+              <a:rPr lang="en-US"/>
               <a:t>Click to edit Master title style</a:t>
             </a:r>
-            <a:endParaRPr lang="en-US"/>
           </a:p>
         </p:txBody>
       </p:sp>
@@ -2660,38 +2656,37 @@
           <a:p>
             <a:pPr lvl="0"/>
             <a:r>
-              <a:rPr lang="en-US" smtClean="0"/>
+              <a:rPr lang="en-US"/>
               <a:t>Click to edit Master text styles</a:t>
             </a:r>
           </a:p>
           <a:p>
             <a:pPr lvl="1"/>
             <a:r>
-              <a:rPr lang="en-US" smtClean="0"/>
+              <a:rPr lang="en-US"/>
               <a:t>Second level</a:t>
             </a:r>
           </a:p>
           <a:p>
             <a:pPr lvl="2"/>
             <a:r>
-              <a:rPr lang="en-US" smtClean="0"/>
+              <a:rPr lang="en-US"/>
               <a:t>Third level</a:t>
             </a:r>
           </a:p>
           <a:p>
             <a:pPr lvl="3"/>
             <a:r>
-              <a:rPr lang="en-US" smtClean="0"/>
+              <a:rPr lang="en-US"/>
               <a:t>Fourth level</a:t>
             </a:r>
           </a:p>
           <a:p>
             <a:pPr lvl="4"/>
             <a:r>
-              <a:rPr lang="en-US" smtClean="0"/>
+              <a:rPr lang="en-US"/>
               <a:t>Fifth level</a:t>
             </a:r>
-            <a:endParaRPr lang="en-US"/>
           </a:p>
         </p:txBody>
       </p:sp>
@@ -2730,7 +2725,7 @@
           <a:p>
             <a:fld id="{5BCAD085-E8A6-8845-BD4E-CB4CCA059FC4}" type="datetimeFigureOut">
               <a:rPr lang="en-US" smtClean="0"/>
-              <a:t>1/27/13</a:t>
+              <a:t>9/12/2026</a:t>
             </a:fld>
             <a:endParaRPr lang="en-US"/>
           </a:p>
@@ -3089,7 +3084,7 @@
 </file>
 
 <file path=ppt/slides/slide1.xml><?xml version="1.0" encoding="utf-8"?>
-<p:sld xmlns:a="http://schemas.openxmlformats.org/drawingml/2006/main" xmlns:p="http://schemas.openxmlformats.org/presentationml/2006/main" xmlns:r="http://schemas.openxmlformats.org/officeDocument/2006/relationships">
+<p:sld xmlns:a="http://schemas.openxmlformats.org/drawingml/2006/main" xmlns:r="http://schemas.openxmlformats.org/officeDocument/2006/relationships" xmlns:p="http://schemas.openxmlformats.org/presentationml/2006/main">
   <p:cSld>
     <p:spTree>
       <p:nvGrpSpPr>
@@ -3097,7 +3092,14 @@
         <p:cNvGrpSpPr/>
         <p:nvPr/>
       </p:nvGrpSpPr>
-      <p:grpSpPr/>
+      <p:grpSpPr>
+        <a:xfrm>
+          <a:off x="0" y="0"/>
+          <a:ext cx="0" cy="0"/>
+          <a:chOff x="0" y="0"/>
+          <a:chExt cx="0" cy="0"/>
+        </a:xfrm>
+      </p:grpSpPr>
       <p:sp>
         <p:nvSpPr>
           <p:cNvPr id="2" name="Rectangle 1"/>
@@ -3138,6 +3140,7 @@
           <a:lstStyle/>
           <a:p>
             <a:pPr algn="ctr"/>
+            <a:endParaRPr/>
           </a:p>
         </p:txBody>
       </p:sp>
@@ -3207,6 +3210,7 @@
           <a:lstStyle/>
           <a:p>
             <a:pPr algn="ctr"/>
+            <a:endParaRPr/>
           </a:p>
         </p:txBody>
       </p:sp>
@@ -3257,7 +3261,7 @@
           <a:lstStyle/>
           <a:p>
             <a:r>
-              <a:rPr b="1" sz="1300">
+              <a:rPr sz="1300" b="1">
                 <a:solidFill>
                   <a:srgbClr val="4F46E5"/>
                 </a:solidFill>
@@ -3266,7 +3270,7 @@
               <a:t>CompliScan </a:t>
             </a:r>
             <a:r>
-              <a:rPr b="1" sz="1300">
+              <a:rPr sz="1300" b="1">
                 <a:solidFill>
                   <a:srgbClr val="10B981"/>
                 </a:solidFill>
@@ -3291,7 +3295,7 @@
       <p:sp>
         <p:nvSpPr>
           <p:cNvPr id="7" name="Rounded Rectangle 6">
-            <a:hlinkClick action="ppaction://hlinksldjump" r:id="rId4"/>
+            <a:hlinkClick r:id="rId4" action="ppaction://hlinksldjump"/>
           </p:cNvPr>
           <p:cNvSpPr/>
           <p:nvPr/>
@@ -3326,7 +3330,7 @@
           </a:fontRef>
         </p:style>
         <p:txBody>
-          <a:bodyPr rtlCol="0" anchor="ctr" wrap="square" lIns="73152" rIns="73152" tIns="36576" bIns="36576"/>
+          <a:bodyPr wrap="square" lIns="73152" tIns="36576" rIns="73152" bIns="36576" rtlCol="0" anchor="ctr"/>
           <a:lstStyle/>
           <a:p>
             <a:pPr algn="ctr"/>
@@ -3345,7 +3349,7 @@
       <p:sp>
         <p:nvSpPr>
           <p:cNvPr id="8" name="Rounded Rectangle 7">
-            <a:hlinkClick action="ppaction://hlinksldjump" r:id="rId5"/>
+            <a:hlinkClick r:id="rId5" action="ppaction://hlinksldjump"/>
           </p:cNvPr>
           <p:cNvSpPr/>
           <p:nvPr/>
@@ -3380,7 +3384,7 @@
           </a:fontRef>
         </p:style>
         <p:txBody>
-          <a:bodyPr rtlCol="0" anchor="ctr" wrap="square" lIns="73152" rIns="73152" tIns="36576" bIns="36576"/>
+          <a:bodyPr wrap="square" lIns="73152" tIns="36576" rIns="73152" bIns="36576" rtlCol="0" anchor="ctr"/>
           <a:lstStyle/>
           <a:p>
             <a:pPr algn="ctr"/>
@@ -3399,7 +3403,7 @@
       <p:sp>
         <p:nvSpPr>
           <p:cNvPr id="9" name="Rounded Rectangle 8">
-            <a:hlinkClick action="ppaction://hlinksldjump" r:id="rId6"/>
+            <a:hlinkClick r:id="rId6" action="ppaction://hlinksldjump"/>
           </p:cNvPr>
           <p:cNvSpPr/>
           <p:nvPr/>
@@ -3434,7 +3438,7 @@
           </a:fontRef>
         </p:style>
         <p:txBody>
-          <a:bodyPr rtlCol="0" anchor="ctr" wrap="square" lIns="73152" rIns="73152" tIns="36576" bIns="36576"/>
+          <a:bodyPr wrap="square" lIns="73152" tIns="36576" rIns="73152" bIns="36576" rtlCol="0" anchor="ctr"/>
           <a:lstStyle/>
           <a:p>
             <a:pPr algn="ctr"/>
@@ -3453,7 +3457,7 @@
       <p:sp>
         <p:nvSpPr>
           <p:cNvPr id="10" name="Rounded Rectangle 9">
-            <a:hlinkClick action="ppaction://hlinksldjump" r:id="rId7"/>
+            <a:hlinkClick r:id="rId7" action="ppaction://hlinksldjump"/>
           </p:cNvPr>
           <p:cNvSpPr/>
           <p:nvPr/>
@@ -3488,7 +3492,7 @@
           </a:fontRef>
         </p:style>
         <p:txBody>
-          <a:bodyPr rtlCol="0" anchor="ctr" wrap="square" lIns="73152" rIns="73152" tIns="36576" bIns="36576"/>
+          <a:bodyPr wrap="square" lIns="73152" tIns="36576" rIns="73152" bIns="36576" rtlCol="0" anchor="ctr"/>
           <a:lstStyle/>
           <a:p>
             <a:pPr algn="ctr"/>
@@ -3507,7 +3511,7 @@
       <p:sp>
         <p:nvSpPr>
           <p:cNvPr id="11" name="Rounded Rectangle 10">
-            <a:hlinkClick action="ppaction://hlinksldjump" r:id="rId8"/>
+            <a:hlinkClick r:id="rId8" action="ppaction://hlinksldjump"/>
           </p:cNvPr>
           <p:cNvSpPr/>
           <p:nvPr/>
@@ -3542,7 +3546,7 @@
           </a:fontRef>
         </p:style>
         <p:txBody>
-          <a:bodyPr rtlCol="0" anchor="ctr" wrap="square" lIns="73152" rIns="73152" tIns="36576" bIns="36576"/>
+          <a:bodyPr wrap="square" lIns="73152" tIns="36576" rIns="73152" bIns="36576" rtlCol="0" anchor="ctr"/>
           <a:lstStyle/>
           <a:p>
             <a:pPr algn="ctr"/>
@@ -3561,7 +3565,7 @@
       <p:sp>
         <p:nvSpPr>
           <p:cNvPr id="12" name="Rounded Rectangle 11">
-            <a:hlinkClick action="ppaction://hlinksldjump" r:id="rId9"/>
+            <a:hlinkClick r:id="rId9" action="ppaction://hlinksldjump"/>
           </p:cNvPr>
           <p:cNvSpPr/>
           <p:nvPr/>
@@ -3596,7 +3600,7 @@
           </a:fontRef>
         </p:style>
         <p:txBody>
-          <a:bodyPr rtlCol="0" anchor="ctr" wrap="square" lIns="73152" rIns="73152" tIns="36576" bIns="36576"/>
+          <a:bodyPr wrap="square" lIns="73152" tIns="36576" rIns="73152" bIns="36576" rtlCol="0" anchor="ctr"/>
           <a:lstStyle/>
           <a:p>
             <a:pPr algn="ctr"/>
@@ -3615,7 +3619,7 @@
       <p:sp>
         <p:nvSpPr>
           <p:cNvPr id="13" name="Rounded Rectangle 12">
-            <a:hlinkClick action="ppaction://hlinksldjump" r:id="rId10"/>
+            <a:hlinkClick r:id="rId10" action="ppaction://hlinksldjump"/>
           </p:cNvPr>
           <p:cNvSpPr/>
           <p:nvPr/>
@@ -3650,7 +3654,7 @@
           </a:fontRef>
         </p:style>
         <p:txBody>
-          <a:bodyPr rtlCol="0" anchor="ctr" wrap="square" lIns="73152" rIns="73152" tIns="36576" bIns="36576"/>
+          <a:bodyPr wrap="square" lIns="73152" tIns="36576" rIns="73152" bIns="36576" rtlCol="0" anchor="ctr"/>
           <a:lstStyle/>
           <a:p>
             <a:pPr algn="ctr"/>
@@ -3708,6 +3712,7 @@
           <a:lstStyle/>
           <a:p>
             <a:pPr algn="ctr"/>
+            <a:endParaRPr/>
           </a:p>
         </p:txBody>
       </p:sp>
@@ -3801,6 +3806,7 @@
           <a:lstStyle/>
           <a:p>
             <a:pPr algn="ctr"/>
+            <a:endParaRPr/>
           </a:p>
         </p:txBody>
       </p:sp>
@@ -3876,7 +3882,7 @@
       <p:sp>
         <p:nvSpPr>
           <p:cNvPr id="20" name="Rounded Rectangle 19">
-            <a:hlinkClick action="ppaction://hlinksldjump" r:id="rId4"/>
+            <a:hlinkClick r:id="rId4" action="ppaction://hlinksldjump"/>
           </p:cNvPr>
           <p:cNvSpPr/>
           <p:nvPr/>
@@ -3913,7 +3919,7 @@
           </a:fontRef>
         </p:style>
         <p:txBody>
-          <a:bodyPr rtlCol="0" anchor="ctr" wrap="square" lIns="73152" rIns="73152" tIns="36576" bIns="36576"/>
+          <a:bodyPr wrap="square" lIns="73152" tIns="36576" rIns="73152" bIns="36576" rtlCol="0" anchor="ctr"/>
           <a:lstStyle/>
           <a:p>
             <a:pPr algn="ctr"/>
@@ -3932,7 +3938,7 @@
       <p:sp>
         <p:nvSpPr>
           <p:cNvPr id="21" name="Rounded Rectangle 20">
-            <a:hlinkClick action="ppaction://hlinksldjump" r:id="rId13"/>
+            <a:hlinkClick r:id="rId13" action="ppaction://hlinksldjump"/>
           </p:cNvPr>
           <p:cNvSpPr/>
           <p:nvPr/>
@@ -3967,12 +3973,12 @@
           </a:fontRef>
         </p:style>
         <p:txBody>
-          <a:bodyPr rtlCol="0" anchor="ctr" wrap="square" lIns="73152" rIns="73152" tIns="36576" bIns="36576"/>
-          <a:lstStyle/>
-          <a:p>
-            <a:pPr algn="ctr"/>
-            <a:r>
-              <a:rPr sz="850" b="1">
+          <a:bodyPr wrap="square" lIns="73152" tIns="36576" rIns="73152" bIns="36576" rtlCol="0" anchor="ctr"/>
+          <a:lstStyle/>
+          <a:p>
+            <a:pPr algn="ctr"/>
+            <a:r>
+              <a:rPr sz="850" b="1" dirty="0">
                 <a:solidFill>
                   <a:srgbClr val="FFFFFF"/>
                 </a:solidFill>
@@ -4025,6 +4031,7 @@
           <a:lstStyle/>
           <a:p>
             <a:pPr algn="ctr"/>
+            <a:endParaRPr/>
           </a:p>
         </p:txBody>
       </p:sp>
@@ -4070,6 +4077,7 @@
           <a:lstStyle/>
           <a:p>
             <a:pPr algn="ctr"/>
+            <a:endParaRPr/>
           </a:p>
         </p:txBody>
       </p:sp>
@@ -4248,7 +4256,7 @@
       <p:sp>
         <p:nvSpPr>
           <p:cNvPr id="29" name="Rounded Rectangle 28">
-            <a:hlinkClick action="ppaction://hlinksldjump" r:id="rId6"/>
+            <a:hlinkClick r:id="rId6" action="ppaction://hlinksldjump"/>
           </p:cNvPr>
           <p:cNvSpPr/>
           <p:nvPr/>
@@ -4283,7 +4291,7 @@
           </a:fontRef>
         </p:style>
         <p:txBody>
-          <a:bodyPr rtlCol="0" anchor="ctr" wrap="square" lIns="73152" rIns="73152" tIns="36576" bIns="36576"/>
+          <a:bodyPr wrap="square" lIns="73152" tIns="36576" rIns="73152" bIns="36576" rtlCol="0" anchor="ctr"/>
           <a:lstStyle/>
           <a:p>
             <a:pPr algn="ctr"/>
@@ -4302,7 +4310,7 @@
       <p:sp>
         <p:nvSpPr>
           <p:cNvPr id="30" name="Rounded Rectangle 29">
-            <a:hlinkClick action="ppaction://hlinksldjump" r:id="rId5"/>
+            <a:hlinkClick r:id="rId5" action="ppaction://hlinksldjump"/>
           </p:cNvPr>
           <p:cNvSpPr/>
           <p:nvPr/>
@@ -4339,7 +4347,7 @@
           </a:fontRef>
         </p:style>
         <p:txBody>
-          <a:bodyPr rtlCol="0" anchor="ctr" wrap="square" lIns="73152" rIns="73152" tIns="36576" bIns="36576"/>
+          <a:bodyPr wrap="square" lIns="73152" tIns="36576" rIns="73152" bIns="36576" rtlCol="0" anchor="ctr"/>
           <a:lstStyle/>
           <a:p>
             <a:pPr algn="ctr"/>
@@ -4358,7 +4366,7 @@
       <p:sp>
         <p:nvSpPr>
           <p:cNvPr id="31" name="Rounded Rectangle 30">
-            <a:hlinkClick action="ppaction://hlinksldjump" r:id="rId7"/>
+            <a:hlinkClick r:id="rId7" action="ppaction://hlinksldjump"/>
           </p:cNvPr>
           <p:cNvSpPr/>
           <p:nvPr/>
@@ -4395,7 +4403,7 @@
           </a:fontRef>
         </p:style>
         <p:txBody>
-          <a:bodyPr rtlCol="0" anchor="ctr" wrap="square" lIns="73152" rIns="73152" tIns="36576" bIns="36576"/>
+          <a:bodyPr wrap="square" lIns="73152" tIns="36576" rIns="73152" bIns="36576" rtlCol="0" anchor="ctr"/>
           <a:lstStyle/>
           <a:p>
             <a:pPr algn="ctr"/>
@@ -4451,6 +4459,7 @@
           <a:lstStyle/>
           <a:p>
             <a:pPr algn="ctr"/>
+            <a:endParaRPr/>
           </a:p>
         </p:txBody>
       </p:sp>
@@ -4540,6 +4549,7 @@
           <a:lstStyle/>
           <a:p>
             <a:pPr algn="ctr"/>
+            <a:endParaRPr/>
           </a:p>
         </p:txBody>
       </p:sp>
@@ -4629,6 +4639,7 @@
           <a:lstStyle/>
           <a:p>
             <a:pPr algn="ctr"/>
+            <a:endParaRPr/>
           </a:p>
         </p:txBody>
       </p:sp>
@@ -4718,6 +4729,7 @@
           <a:lstStyle/>
           <a:p>
             <a:pPr algn="ctr"/>
+            <a:endParaRPr/>
           </a:p>
         </p:txBody>
       </p:sp>
@@ -4763,6 +4775,7 @@
           <a:lstStyle/>
           <a:p>
             <a:pPr algn="ctr"/>
+            <a:endParaRPr/>
           </a:p>
         </p:txBody>
       </p:sp>
@@ -4857,6 +4870,7 @@
           <a:lstStyle/>
           <a:p>
             <a:pPr algn="ctr"/>
+            <a:endParaRPr/>
           </a:p>
         </p:txBody>
       </p:sp>
@@ -4913,7 +4927,7 @@
 </file>
 
 <file path=ppt/slides/slide10.xml><?xml version="1.0" encoding="utf-8"?>
-<p:sld xmlns:a="http://schemas.openxmlformats.org/drawingml/2006/main" xmlns:p="http://schemas.openxmlformats.org/presentationml/2006/main" xmlns:r="http://schemas.openxmlformats.org/officeDocument/2006/relationships">
+<p:sld xmlns:a="http://schemas.openxmlformats.org/drawingml/2006/main" xmlns:r="http://schemas.openxmlformats.org/officeDocument/2006/relationships" xmlns:p="http://schemas.openxmlformats.org/presentationml/2006/main">
   <p:cSld>
     <p:spTree>
       <p:nvGrpSpPr>
@@ -4921,7 +4935,14 @@
         <p:cNvGrpSpPr/>
         <p:nvPr/>
       </p:nvGrpSpPr>
-      <p:grpSpPr/>
+      <p:grpSpPr>
+        <a:xfrm>
+          <a:off x="0" y="0"/>
+          <a:ext cx="0" cy="0"/>
+          <a:chOff x="0" y="0"/>
+          <a:chExt cx="0" cy="0"/>
+        </a:xfrm>
+      </p:grpSpPr>
       <p:sp>
         <p:nvSpPr>
           <p:cNvPr id="2" name="Rectangle 1"/>
@@ -4962,6 +4983,7 @@
           <a:lstStyle/>
           <a:p>
             <a:pPr algn="ctr"/>
+            <a:endParaRPr/>
           </a:p>
         </p:txBody>
       </p:sp>
@@ -5031,6 +5053,7 @@
           <a:lstStyle/>
           <a:p>
             <a:pPr algn="ctr"/>
+            <a:endParaRPr/>
           </a:p>
         </p:txBody>
       </p:sp>
@@ -5081,7 +5104,7 @@
           <a:lstStyle/>
           <a:p>
             <a:r>
-              <a:rPr b="1" sz="1300">
+              <a:rPr sz="1300" b="1">
                 <a:solidFill>
                   <a:srgbClr val="4F46E5"/>
                 </a:solidFill>
@@ -5090,7 +5113,7 @@
               <a:t>CompliScan </a:t>
             </a:r>
             <a:r>
-              <a:rPr b="1" sz="1300">
+              <a:rPr sz="1300" b="1">
                 <a:solidFill>
                   <a:srgbClr val="10B981"/>
                 </a:solidFill>
@@ -5115,7 +5138,7 @@
       <p:sp>
         <p:nvSpPr>
           <p:cNvPr id="7" name="Rounded Rectangle 6">
-            <a:hlinkClick action="ppaction://hlinksldjump" r:id="rId4"/>
+            <a:hlinkClick r:id="rId4" action="ppaction://hlinksldjump"/>
           </p:cNvPr>
           <p:cNvSpPr/>
           <p:nvPr/>
@@ -5150,7 +5173,7 @@
           </a:fontRef>
         </p:style>
         <p:txBody>
-          <a:bodyPr rtlCol="0" anchor="ctr" wrap="square" lIns="73152" rIns="73152" tIns="36576" bIns="36576"/>
+          <a:bodyPr wrap="square" lIns="73152" tIns="36576" rIns="73152" bIns="36576" rtlCol="0" anchor="ctr"/>
           <a:lstStyle/>
           <a:p>
             <a:pPr algn="ctr"/>
@@ -5169,7 +5192,7 @@
       <p:sp>
         <p:nvSpPr>
           <p:cNvPr id="8" name="Rounded Rectangle 7">
-            <a:hlinkClick action="ppaction://hlinksldjump" r:id="rId5"/>
+            <a:hlinkClick r:id="rId5" action="ppaction://hlinksldjump"/>
           </p:cNvPr>
           <p:cNvSpPr/>
           <p:nvPr/>
@@ -5204,7 +5227,7 @@
           </a:fontRef>
         </p:style>
         <p:txBody>
-          <a:bodyPr rtlCol="0" anchor="ctr" wrap="square" lIns="73152" rIns="73152" tIns="36576" bIns="36576"/>
+          <a:bodyPr wrap="square" lIns="73152" tIns="36576" rIns="73152" bIns="36576" rtlCol="0" anchor="ctr"/>
           <a:lstStyle/>
           <a:p>
             <a:pPr algn="ctr"/>
@@ -5223,7 +5246,7 @@
       <p:sp>
         <p:nvSpPr>
           <p:cNvPr id="9" name="Rounded Rectangle 8">
-            <a:hlinkClick action="ppaction://hlinksldjump" r:id="rId6"/>
+            <a:hlinkClick r:id="rId6" action="ppaction://hlinksldjump"/>
           </p:cNvPr>
           <p:cNvSpPr/>
           <p:nvPr/>
@@ -5258,7 +5281,7 @@
           </a:fontRef>
         </p:style>
         <p:txBody>
-          <a:bodyPr rtlCol="0" anchor="ctr" wrap="square" lIns="73152" rIns="73152" tIns="36576" bIns="36576"/>
+          <a:bodyPr wrap="square" lIns="73152" tIns="36576" rIns="73152" bIns="36576" rtlCol="0" anchor="ctr"/>
           <a:lstStyle/>
           <a:p>
             <a:pPr algn="ctr"/>
@@ -5277,7 +5300,7 @@
       <p:sp>
         <p:nvSpPr>
           <p:cNvPr id="10" name="Rounded Rectangle 9">
-            <a:hlinkClick action="ppaction://hlinksldjump" r:id="rId7"/>
+            <a:hlinkClick r:id="rId7" action="ppaction://hlinksldjump"/>
           </p:cNvPr>
           <p:cNvSpPr/>
           <p:nvPr/>
@@ -5312,7 +5335,7 @@
           </a:fontRef>
         </p:style>
         <p:txBody>
-          <a:bodyPr rtlCol="0" anchor="ctr" wrap="square" lIns="73152" rIns="73152" tIns="36576" bIns="36576"/>
+          <a:bodyPr wrap="square" lIns="73152" tIns="36576" rIns="73152" bIns="36576" rtlCol="0" anchor="ctr"/>
           <a:lstStyle/>
           <a:p>
             <a:pPr algn="ctr"/>
@@ -5331,7 +5354,7 @@
       <p:sp>
         <p:nvSpPr>
           <p:cNvPr id="11" name="Rounded Rectangle 10">
-            <a:hlinkClick action="ppaction://hlinksldjump" r:id="rId8"/>
+            <a:hlinkClick r:id="rId8" action="ppaction://hlinksldjump"/>
           </p:cNvPr>
           <p:cNvSpPr/>
           <p:nvPr/>
@@ -5366,7 +5389,7 @@
           </a:fontRef>
         </p:style>
         <p:txBody>
-          <a:bodyPr rtlCol="0" anchor="ctr" wrap="square" lIns="73152" rIns="73152" tIns="36576" bIns="36576"/>
+          <a:bodyPr wrap="square" lIns="73152" tIns="36576" rIns="73152" bIns="36576" rtlCol="0" anchor="ctr"/>
           <a:lstStyle/>
           <a:p>
             <a:pPr algn="ctr"/>
@@ -5385,7 +5408,7 @@
       <p:sp>
         <p:nvSpPr>
           <p:cNvPr id="12" name="Rounded Rectangle 11">
-            <a:hlinkClick action="ppaction://hlinksldjump" r:id="rId9"/>
+            <a:hlinkClick r:id="rId9" action="ppaction://hlinksldjump"/>
           </p:cNvPr>
           <p:cNvSpPr/>
           <p:nvPr/>
@@ -5420,7 +5443,7 @@
           </a:fontRef>
         </p:style>
         <p:txBody>
-          <a:bodyPr rtlCol="0" anchor="ctr" wrap="square" lIns="73152" rIns="73152" tIns="36576" bIns="36576"/>
+          <a:bodyPr wrap="square" lIns="73152" tIns="36576" rIns="73152" bIns="36576" rtlCol="0" anchor="ctr"/>
           <a:lstStyle/>
           <a:p>
             <a:pPr algn="ctr"/>
@@ -5439,7 +5462,7 @@
       <p:sp>
         <p:nvSpPr>
           <p:cNvPr id="13" name="Rounded Rectangle 12">
-            <a:hlinkClick action="ppaction://hlinksldjump" r:id="rId10"/>
+            <a:hlinkClick r:id="rId10" action="ppaction://hlinksldjump"/>
           </p:cNvPr>
           <p:cNvSpPr/>
           <p:nvPr/>
@@ -5474,7 +5497,7 @@
           </a:fontRef>
         </p:style>
         <p:txBody>
-          <a:bodyPr rtlCol="0" anchor="ctr" wrap="square" lIns="73152" rIns="73152" tIns="36576" bIns="36576"/>
+          <a:bodyPr wrap="square" lIns="73152" tIns="36576" rIns="73152" bIns="36576" rtlCol="0" anchor="ctr"/>
           <a:lstStyle/>
           <a:p>
             <a:pPr algn="ctr"/>
@@ -5532,6 +5555,7 @@
           <a:lstStyle/>
           <a:p>
             <a:pPr algn="ctr"/>
+            <a:endParaRPr/>
           </a:p>
         </p:txBody>
       </p:sp>
@@ -5625,6 +5649,7 @@
           <a:lstStyle/>
           <a:p>
             <a:pPr algn="ctr"/>
+            <a:endParaRPr/>
           </a:p>
         </p:txBody>
       </p:sp>
@@ -5700,7 +5725,7 @@
       <p:sp>
         <p:nvSpPr>
           <p:cNvPr id="20" name="Rounded Rectangle 19">
-            <a:hlinkClick action="ppaction://hlinksldjump" r:id="rId13"/>
+            <a:hlinkClick r:id="rId13" action="ppaction://hlinksldjump"/>
           </p:cNvPr>
           <p:cNvSpPr/>
           <p:nvPr/>
@@ -5737,7 +5762,7 @@
           </a:fontRef>
         </p:style>
         <p:txBody>
-          <a:bodyPr rtlCol="0" anchor="ctr" wrap="square" lIns="73152" rIns="73152" tIns="36576" bIns="36576"/>
+          <a:bodyPr wrap="square" lIns="73152" tIns="36576" rIns="73152" bIns="36576" rtlCol="0" anchor="ctr"/>
           <a:lstStyle/>
           <a:p>
             <a:pPr algn="ctr"/>
@@ -5756,7 +5781,7 @@
       <p:sp>
         <p:nvSpPr>
           <p:cNvPr id="21" name="Rounded Rectangle 20">
-            <a:hlinkClick action="ppaction://hlinksldjump" r:id="rId14"/>
+            <a:hlinkClick r:id="rId14" action="ppaction://hlinksldjump"/>
           </p:cNvPr>
           <p:cNvSpPr/>
           <p:nvPr/>
@@ -5791,7 +5816,7 @@
           </a:fontRef>
         </p:style>
         <p:txBody>
-          <a:bodyPr rtlCol="0" anchor="ctr" wrap="square" lIns="73152" rIns="73152" tIns="36576" bIns="36576"/>
+          <a:bodyPr wrap="square" lIns="73152" tIns="36576" rIns="73152" bIns="36576" rtlCol="0" anchor="ctr"/>
           <a:lstStyle/>
           <a:p>
             <a:pPr algn="ctr"/>
@@ -5849,6 +5874,7 @@
           <a:lstStyle/>
           <a:p>
             <a:pPr algn="ctr"/>
+            <a:endParaRPr/>
           </a:p>
         </p:txBody>
       </p:sp>
@@ -5986,6 +6012,7 @@
           <a:lstStyle/>
           <a:p>
             <a:pPr algn="ctr"/>
+            <a:endParaRPr/>
           </a:p>
         </p:txBody>
       </p:sp>
@@ -6022,7 +6049,7 @@
         <p:spPr>
           <a:xfrm>
             <a:off x="1554480" y="2011679"/>
-            <a:ext cx="2468880" cy="1645920"/>
+            <a:ext cx="2468880" cy="777136"/>
           </a:xfrm>
           <a:prstGeom prst="rect">
             <a:avLst/>
@@ -6036,7 +6063,7 @@
           <a:lstStyle/>
           <a:p>
             <a:r>
-              <a:rPr sz="1150" b="1">
+              <a:rPr sz="1150" b="1" dirty="0">
                 <a:solidFill>
                   <a:srgbClr val="0F172A"/>
                 </a:solidFill>
@@ -6045,28 +6072,35 @@
               <a:t>Shubham Kumar
 </a:t>
             </a:r>
-          </a:p>
-          <a:p>
-            <a:r>
-              <a:rPr sz="850" b="1">
+            <a:r>
+              <a:rPr sz="850" b="1" dirty="0">
                 <a:solidFill>
                   <a:srgbClr val="4F46E5"/>
                 </a:solidFill>
                 <a:latin typeface="Segoe UI"/>
               </a:rPr>
-              <a:t>Team Lead &amp; Full-Stack / AI Architect
+              <a:t> Full-Stack / AI Architect
 </a:t>
             </a:r>
           </a:p>
           <a:p>
             <a:r>
-              <a:rPr sz="800">
+              <a:rPr sz="800" dirty="0" err="1">
                 <a:solidFill>
                   <a:srgbClr val="64748B"/>
                 </a:solidFill>
                 <a:latin typeface="Segoe UI"/>
               </a:rPr>
-              <a:t>B.Tech Information Technology
+              <a:t>B.Tech</a:t>
+            </a:r>
+            <a:r>
+              <a:rPr sz="800" dirty="0">
+                <a:solidFill>
+                  <a:srgbClr val="64748B"/>
+                </a:solidFill>
+                <a:latin typeface="Segoe UI"/>
+              </a:rPr>
+              <a:t> Information Technology
 Session: 2024–27 (D2D)</a:t>
             </a:r>
           </a:p>
@@ -6114,6 +6148,7 @@
           <a:lstStyle/>
           <a:p>
             <a:pPr algn="ctr"/>
+            <a:endParaRPr/>
           </a:p>
         </p:txBody>
       </p:sp>
@@ -6159,6 +6194,7 @@
           <a:lstStyle/>
           <a:p>
             <a:pPr algn="ctr"/>
+            <a:endParaRPr/>
           </a:p>
         </p:txBody>
       </p:sp>
@@ -6298,6 +6334,7 @@
           <a:lstStyle/>
           <a:p>
             <a:pPr algn="ctr"/>
+            <a:endParaRPr/>
           </a:p>
         </p:txBody>
       </p:sp>
@@ -6343,6 +6380,7 @@
           <a:lstStyle/>
           <a:p>
             <a:pPr algn="ctr"/>
+            <a:endParaRPr/>
           </a:p>
         </p:txBody>
       </p:sp>
@@ -6482,6 +6520,7 @@
           <a:lstStyle/>
           <a:p>
             <a:pPr algn="ctr"/>
+            <a:endParaRPr/>
           </a:p>
         </p:txBody>
       </p:sp>
@@ -6527,6 +6566,7 @@
           <a:lstStyle/>
           <a:p>
             <a:pPr algn="ctr"/>
+            <a:endParaRPr/>
           </a:p>
         </p:txBody>
       </p:sp>
@@ -6666,6 +6706,7 @@
           <a:lstStyle/>
           <a:p>
             <a:pPr algn="ctr"/>
+            <a:endParaRPr/>
           </a:p>
         </p:txBody>
       </p:sp>
@@ -6711,6 +6752,7 @@
           <a:lstStyle/>
           <a:p>
             <a:pPr algn="ctr"/>
+            <a:endParaRPr/>
           </a:p>
         </p:txBody>
       </p:sp>
@@ -6850,6 +6892,7 @@
           <a:lstStyle/>
           <a:p>
             <a:pPr algn="ctr"/>
+            <a:endParaRPr/>
           </a:p>
         </p:txBody>
       </p:sp>
@@ -6895,6 +6938,7 @@
           <a:lstStyle/>
           <a:p>
             <a:pPr algn="ctr"/>
+            <a:endParaRPr/>
           </a:p>
         </p:txBody>
       </p:sp>
@@ -6995,7 +7039,7 @@
       <p:sp>
         <p:nvSpPr>
           <p:cNvPr id="49" name="Rounded Rectangle 48">
-            <a:hlinkClick action="ppaction://hlinksldjump" r:id="rId14"/>
+            <a:hlinkClick r:id="rId14" action="ppaction://hlinksldjump"/>
           </p:cNvPr>
           <p:cNvSpPr/>
           <p:nvPr/>
@@ -7030,7 +7074,7 @@
           </a:fontRef>
         </p:style>
         <p:txBody>
-          <a:bodyPr rtlCol="0" anchor="ctr" wrap="square" lIns="73152" rIns="73152" tIns="36576" bIns="36576"/>
+          <a:bodyPr wrap="square" lIns="73152" tIns="36576" rIns="73152" bIns="36576" rtlCol="0" anchor="ctr"/>
           <a:lstStyle/>
           <a:p>
             <a:pPr algn="ctr"/>
@@ -7055,7 +7099,7 @@
 </file>
 
 <file path=ppt/slides/slide11.xml><?xml version="1.0" encoding="utf-8"?>
-<p:sld xmlns:a="http://schemas.openxmlformats.org/drawingml/2006/main" xmlns:p="http://schemas.openxmlformats.org/presentationml/2006/main" xmlns:r="http://schemas.openxmlformats.org/officeDocument/2006/relationships">
+<p:sld xmlns:a="http://schemas.openxmlformats.org/drawingml/2006/main" xmlns:r="http://schemas.openxmlformats.org/officeDocument/2006/relationships" xmlns:p="http://schemas.openxmlformats.org/presentationml/2006/main">
   <p:cSld>
     <p:spTree>
       <p:nvGrpSpPr>
@@ -7063,7 +7107,14 @@
         <p:cNvGrpSpPr/>
         <p:nvPr/>
       </p:nvGrpSpPr>
-      <p:grpSpPr/>
+      <p:grpSpPr>
+        <a:xfrm>
+          <a:off x="0" y="0"/>
+          <a:ext cx="0" cy="0"/>
+          <a:chOff x="0" y="0"/>
+          <a:chExt cx="0" cy="0"/>
+        </a:xfrm>
+      </p:grpSpPr>
       <p:sp>
         <p:nvSpPr>
           <p:cNvPr id="2" name="Rectangle 1"/>
@@ -7104,6 +7155,7 @@
           <a:lstStyle/>
           <a:p>
             <a:pPr algn="ctr"/>
+            <a:endParaRPr/>
           </a:p>
         </p:txBody>
       </p:sp>
@@ -7173,6 +7225,7 @@
           <a:lstStyle/>
           <a:p>
             <a:pPr algn="ctr"/>
+            <a:endParaRPr/>
           </a:p>
         </p:txBody>
       </p:sp>
@@ -7223,7 +7276,7 @@
           <a:lstStyle/>
           <a:p>
             <a:r>
-              <a:rPr b="1" sz="1300">
+              <a:rPr sz="1300" b="1">
                 <a:solidFill>
                   <a:srgbClr val="4F46E5"/>
                 </a:solidFill>
@@ -7232,7 +7285,7 @@
               <a:t>CompliScan </a:t>
             </a:r>
             <a:r>
-              <a:rPr b="1" sz="1300">
+              <a:rPr sz="1300" b="1">
                 <a:solidFill>
                   <a:srgbClr val="10B981"/>
                 </a:solidFill>
@@ -7257,7 +7310,7 @@
       <p:sp>
         <p:nvSpPr>
           <p:cNvPr id="7" name="Rounded Rectangle 6">
-            <a:hlinkClick action="ppaction://hlinksldjump" r:id="rId4"/>
+            <a:hlinkClick r:id="rId4" action="ppaction://hlinksldjump"/>
           </p:cNvPr>
           <p:cNvSpPr/>
           <p:nvPr/>
@@ -7292,7 +7345,7 @@
           </a:fontRef>
         </p:style>
         <p:txBody>
-          <a:bodyPr rtlCol="0" anchor="ctr" wrap="square" lIns="73152" rIns="73152" tIns="36576" bIns="36576"/>
+          <a:bodyPr wrap="square" lIns="73152" tIns="36576" rIns="73152" bIns="36576" rtlCol="0" anchor="ctr"/>
           <a:lstStyle/>
           <a:p>
             <a:pPr algn="ctr"/>
@@ -7311,7 +7364,7 @@
       <p:sp>
         <p:nvSpPr>
           <p:cNvPr id="8" name="Rounded Rectangle 7">
-            <a:hlinkClick action="ppaction://hlinksldjump" r:id="rId5"/>
+            <a:hlinkClick r:id="rId5" action="ppaction://hlinksldjump"/>
           </p:cNvPr>
           <p:cNvSpPr/>
           <p:nvPr/>
@@ -7346,7 +7399,7 @@
           </a:fontRef>
         </p:style>
         <p:txBody>
-          <a:bodyPr rtlCol="0" anchor="ctr" wrap="square" lIns="73152" rIns="73152" tIns="36576" bIns="36576"/>
+          <a:bodyPr wrap="square" lIns="73152" tIns="36576" rIns="73152" bIns="36576" rtlCol="0" anchor="ctr"/>
           <a:lstStyle/>
           <a:p>
             <a:pPr algn="ctr"/>
@@ -7365,7 +7418,7 @@
       <p:sp>
         <p:nvSpPr>
           <p:cNvPr id="9" name="Rounded Rectangle 8">
-            <a:hlinkClick action="ppaction://hlinksldjump" r:id="rId6"/>
+            <a:hlinkClick r:id="rId6" action="ppaction://hlinksldjump"/>
           </p:cNvPr>
           <p:cNvSpPr/>
           <p:nvPr/>
@@ -7400,7 +7453,7 @@
           </a:fontRef>
         </p:style>
         <p:txBody>
-          <a:bodyPr rtlCol="0" anchor="ctr" wrap="square" lIns="73152" rIns="73152" tIns="36576" bIns="36576"/>
+          <a:bodyPr wrap="square" lIns="73152" tIns="36576" rIns="73152" bIns="36576" rtlCol="0" anchor="ctr"/>
           <a:lstStyle/>
           <a:p>
             <a:pPr algn="ctr"/>
@@ -7419,7 +7472,7 @@
       <p:sp>
         <p:nvSpPr>
           <p:cNvPr id="10" name="Rounded Rectangle 9">
-            <a:hlinkClick action="ppaction://hlinksldjump" r:id="rId7"/>
+            <a:hlinkClick r:id="rId7" action="ppaction://hlinksldjump"/>
           </p:cNvPr>
           <p:cNvSpPr/>
           <p:nvPr/>
@@ -7454,7 +7507,7 @@
           </a:fontRef>
         </p:style>
         <p:txBody>
-          <a:bodyPr rtlCol="0" anchor="ctr" wrap="square" lIns="73152" rIns="73152" tIns="36576" bIns="36576"/>
+          <a:bodyPr wrap="square" lIns="73152" tIns="36576" rIns="73152" bIns="36576" rtlCol="0" anchor="ctr"/>
           <a:lstStyle/>
           <a:p>
             <a:pPr algn="ctr"/>
@@ -7473,7 +7526,7 @@
       <p:sp>
         <p:nvSpPr>
           <p:cNvPr id="11" name="Rounded Rectangle 10">
-            <a:hlinkClick action="ppaction://hlinksldjump" r:id="rId8"/>
+            <a:hlinkClick r:id="rId8" action="ppaction://hlinksldjump"/>
           </p:cNvPr>
           <p:cNvSpPr/>
           <p:nvPr/>
@@ -7508,7 +7561,7 @@
           </a:fontRef>
         </p:style>
         <p:txBody>
-          <a:bodyPr rtlCol="0" anchor="ctr" wrap="square" lIns="73152" rIns="73152" tIns="36576" bIns="36576"/>
+          <a:bodyPr wrap="square" lIns="73152" tIns="36576" rIns="73152" bIns="36576" rtlCol="0" anchor="ctr"/>
           <a:lstStyle/>
           <a:p>
             <a:pPr algn="ctr"/>
@@ -7527,7 +7580,7 @@
       <p:sp>
         <p:nvSpPr>
           <p:cNvPr id="12" name="Rounded Rectangle 11">
-            <a:hlinkClick action="ppaction://hlinksldjump" r:id="rId9"/>
+            <a:hlinkClick r:id="rId9" action="ppaction://hlinksldjump"/>
           </p:cNvPr>
           <p:cNvSpPr/>
           <p:nvPr/>
@@ -7562,7 +7615,7 @@
           </a:fontRef>
         </p:style>
         <p:txBody>
-          <a:bodyPr rtlCol="0" anchor="ctr" wrap="square" lIns="73152" rIns="73152" tIns="36576" bIns="36576"/>
+          <a:bodyPr wrap="square" lIns="73152" tIns="36576" rIns="73152" bIns="36576" rtlCol="0" anchor="ctr"/>
           <a:lstStyle/>
           <a:p>
             <a:pPr algn="ctr"/>
@@ -7581,7 +7634,7 @@
       <p:sp>
         <p:nvSpPr>
           <p:cNvPr id="13" name="Rounded Rectangle 12">
-            <a:hlinkClick action="ppaction://hlinksldjump" r:id="rId10"/>
+            <a:hlinkClick r:id="rId10" action="ppaction://hlinksldjump"/>
           </p:cNvPr>
           <p:cNvSpPr/>
           <p:nvPr/>
@@ -7616,7 +7669,7 @@
           </a:fontRef>
         </p:style>
         <p:txBody>
-          <a:bodyPr rtlCol="0" anchor="ctr" wrap="square" lIns="73152" rIns="73152" tIns="36576" bIns="36576"/>
+          <a:bodyPr wrap="square" lIns="73152" tIns="36576" rIns="73152" bIns="36576" rtlCol="0" anchor="ctr"/>
           <a:lstStyle/>
           <a:p>
             <a:pPr algn="ctr"/>
@@ -7674,6 +7727,7 @@
           <a:lstStyle/>
           <a:p>
             <a:pPr algn="ctr"/>
+            <a:endParaRPr/>
           </a:p>
         </p:txBody>
       </p:sp>
@@ -7767,6 +7821,7 @@
           <a:lstStyle/>
           <a:p>
             <a:pPr algn="ctr"/>
+            <a:endParaRPr/>
           </a:p>
         </p:txBody>
       </p:sp>
@@ -7842,7 +7897,7 @@
       <p:sp>
         <p:nvSpPr>
           <p:cNvPr id="20" name="Rounded Rectangle 19">
-            <a:hlinkClick action="ppaction://hlinksldjump" r:id="rId10"/>
+            <a:hlinkClick r:id="rId10" action="ppaction://hlinksldjump"/>
           </p:cNvPr>
           <p:cNvSpPr/>
           <p:nvPr/>
@@ -7879,7 +7934,7 @@
           </a:fontRef>
         </p:style>
         <p:txBody>
-          <a:bodyPr rtlCol="0" anchor="ctr" wrap="square" lIns="73152" rIns="73152" tIns="36576" bIns="36576"/>
+          <a:bodyPr wrap="square" lIns="73152" tIns="36576" rIns="73152" bIns="36576" rtlCol="0" anchor="ctr"/>
           <a:lstStyle/>
           <a:p>
             <a:pPr algn="ctr"/>
@@ -7898,7 +7953,7 @@
       <p:sp>
         <p:nvSpPr>
           <p:cNvPr id="21" name="Rounded Rectangle 20">
-            <a:hlinkClick action="ppaction://hlinksldjump" r:id="rId13"/>
+            <a:hlinkClick r:id="rId13" action="ppaction://hlinksldjump"/>
           </p:cNvPr>
           <p:cNvSpPr/>
           <p:nvPr/>
@@ -7933,7 +7988,7 @@
           </a:fontRef>
         </p:style>
         <p:txBody>
-          <a:bodyPr rtlCol="0" anchor="ctr" wrap="square" lIns="73152" rIns="73152" tIns="36576" bIns="36576"/>
+          <a:bodyPr wrap="square" lIns="73152" tIns="36576" rIns="73152" bIns="36576" rtlCol="0" anchor="ctr"/>
           <a:lstStyle/>
           <a:p>
             <a:pPr algn="ctr"/>
@@ -7991,6 +8046,7 @@
           <a:lstStyle/>
           <a:p>
             <a:pPr algn="ctr"/>
+            <a:endParaRPr/>
           </a:p>
         </p:txBody>
       </p:sp>
@@ -8036,6 +8092,7 @@
           <a:lstStyle/>
           <a:p>
             <a:pPr algn="ctr"/>
+            <a:endParaRPr/>
           </a:p>
         </p:txBody>
       </p:sp>
@@ -8216,7 +8273,7 @@
       <p:sp>
         <p:nvSpPr>
           <p:cNvPr id="29" name="Rounded Rectangle 28">
-            <a:hlinkClick action="ppaction://hlinksldjump" r:id="rId4"/>
+            <a:hlinkClick r:id="rId4" action="ppaction://hlinksldjump"/>
           </p:cNvPr>
           <p:cNvSpPr/>
           <p:nvPr/>
@@ -8253,7 +8310,7 @@
           </a:fontRef>
         </p:style>
         <p:txBody>
-          <a:bodyPr rtlCol="0" anchor="ctr" wrap="square" lIns="73152" rIns="73152" tIns="36576" bIns="36576"/>
+          <a:bodyPr wrap="square" lIns="73152" tIns="36576" rIns="73152" bIns="36576" rtlCol="0" anchor="ctr"/>
           <a:lstStyle/>
           <a:p>
             <a:pPr algn="ctr"/>
@@ -8272,7 +8329,7 @@
       <p:sp>
         <p:nvSpPr>
           <p:cNvPr id="30" name="Rounded Rectangle 29">
-            <a:hlinkClick action="ppaction://hlinksldjump" r:id="rId6"/>
+            <a:hlinkClick r:id="rId6" action="ppaction://hlinksldjump"/>
           </p:cNvPr>
           <p:cNvSpPr/>
           <p:nvPr/>
@@ -8307,7 +8364,7 @@
           </a:fontRef>
         </p:style>
         <p:txBody>
-          <a:bodyPr rtlCol="0" anchor="ctr" wrap="square" lIns="73152" rIns="73152" tIns="36576" bIns="36576"/>
+          <a:bodyPr wrap="square" lIns="73152" tIns="36576" rIns="73152" bIns="36576" rtlCol="0" anchor="ctr"/>
           <a:lstStyle/>
           <a:p>
             <a:pPr algn="ctr"/>
@@ -8326,7 +8383,7 @@
       <p:sp>
         <p:nvSpPr>
           <p:cNvPr id="31" name="Rounded Rectangle 30">
-            <a:hlinkClick action="ppaction://hlinksldjump" r:id="rId7"/>
+            <a:hlinkClick r:id="rId7" action="ppaction://hlinksldjump"/>
           </p:cNvPr>
           <p:cNvSpPr/>
           <p:nvPr/>
@@ -8363,7 +8420,7 @@
           </a:fontRef>
         </p:style>
         <p:txBody>
-          <a:bodyPr rtlCol="0" anchor="ctr" wrap="square" lIns="73152" rIns="73152" tIns="36576" bIns="36576"/>
+          <a:bodyPr wrap="square" lIns="73152" tIns="36576" rIns="73152" bIns="36576" rtlCol="0" anchor="ctr"/>
           <a:lstStyle/>
           <a:p>
             <a:pPr algn="ctr"/>
@@ -8382,7 +8439,7 @@
       <p:sp>
         <p:nvSpPr>
           <p:cNvPr id="32" name="Rounded Rectangle 31">
-            <a:hlinkClick action="ppaction://hlinksldjump" r:id="rId8"/>
+            <a:hlinkClick r:id="rId8" action="ppaction://hlinksldjump"/>
           </p:cNvPr>
           <p:cNvSpPr/>
           <p:nvPr/>
@@ -8417,7 +8474,7 @@
           </a:fontRef>
         </p:style>
         <p:txBody>
-          <a:bodyPr rtlCol="0" anchor="ctr" wrap="square" lIns="73152" rIns="73152" tIns="36576" bIns="36576"/>
+          <a:bodyPr wrap="square" lIns="73152" tIns="36576" rIns="73152" bIns="36576" rtlCol="0" anchor="ctr"/>
           <a:lstStyle/>
           <a:p>
             <a:pPr algn="ctr"/>
@@ -8436,7 +8493,7 @@
       <p:sp>
         <p:nvSpPr>
           <p:cNvPr id="33" name="Rounded Rectangle 32">
-            <a:hlinkClick action="ppaction://hlinksldjump" r:id="rId9"/>
+            <a:hlinkClick r:id="rId9" action="ppaction://hlinksldjump"/>
           </p:cNvPr>
           <p:cNvSpPr/>
           <p:nvPr/>
@@ -8473,7 +8530,7 @@
           </a:fontRef>
         </p:style>
         <p:txBody>
-          <a:bodyPr rtlCol="0" anchor="ctr" wrap="square" lIns="73152" rIns="73152" tIns="36576" bIns="36576"/>
+          <a:bodyPr wrap="square" lIns="73152" tIns="36576" rIns="73152" bIns="36576" rtlCol="0" anchor="ctr"/>
           <a:lstStyle/>
           <a:p>
             <a:pPr algn="ctr"/>
@@ -8534,7 +8591,7 @@
 </file>
 
 <file path=ppt/slides/slide2.xml><?xml version="1.0" encoding="utf-8"?>
-<p:sld xmlns:a="http://schemas.openxmlformats.org/drawingml/2006/main" xmlns:p="http://schemas.openxmlformats.org/presentationml/2006/main" xmlns:r="http://schemas.openxmlformats.org/officeDocument/2006/relationships">
+<p:sld xmlns:a="http://schemas.openxmlformats.org/drawingml/2006/main" xmlns:r="http://schemas.openxmlformats.org/officeDocument/2006/relationships" xmlns:p="http://schemas.openxmlformats.org/presentationml/2006/main">
   <p:cSld>
     <p:spTree>
       <p:nvGrpSpPr>
@@ -8542,7 +8599,14 @@
         <p:cNvGrpSpPr/>
         <p:nvPr/>
       </p:nvGrpSpPr>
-      <p:grpSpPr/>
+      <p:grpSpPr>
+        <a:xfrm>
+          <a:off x="0" y="0"/>
+          <a:ext cx="0" cy="0"/>
+          <a:chOff x="0" y="0"/>
+          <a:chExt cx="0" cy="0"/>
+        </a:xfrm>
+      </p:grpSpPr>
       <p:sp>
         <p:nvSpPr>
           <p:cNvPr id="2" name="Rectangle 1"/>
@@ -8583,6 +8647,7 @@
           <a:lstStyle/>
           <a:p>
             <a:pPr algn="ctr"/>
+            <a:endParaRPr/>
           </a:p>
         </p:txBody>
       </p:sp>
@@ -8652,6 +8717,7 @@
           <a:lstStyle/>
           <a:p>
             <a:pPr algn="ctr"/>
+            <a:endParaRPr/>
           </a:p>
         </p:txBody>
       </p:sp>
@@ -8702,7 +8768,7 @@
           <a:lstStyle/>
           <a:p>
             <a:r>
-              <a:rPr b="1" sz="1300">
+              <a:rPr sz="1300" b="1">
                 <a:solidFill>
                   <a:srgbClr val="4F46E5"/>
                 </a:solidFill>
@@ -8711,7 +8777,7 @@
               <a:t>CompliScan </a:t>
             </a:r>
             <a:r>
-              <a:rPr b="1" sz="1300">
+              <a:rPr sz="1300" b="1">
                 <a:solidFill>
                   <a:srgbClr val="10B981"/>
                 </a:solidFill>
@@ -8736,7 +8802,7 @@
       <p:sp>
         <p:nvSpPr>
           <p:cNvPr id="7" name="Rounded Rectangle 6">
-            <a:hlinkClick action="ppaction://hlinksldjump" r:id="rId4"/>
+            <a:hlinkClick r:id="rId4" action="ppaction://hlinksldjump"/>
           </p:cNvPr>
           <p:cNvSpPr/>
           <p:nvPr/>
@@ -8771,7 +8837,7 @@
           </a:fontRef>
         </p:style>
         <p:txBody>
-          <a:bodyPr rtlCol="0" anchor="ctr" wrap="square" lIns="73152" rIns="73152" tIns="36576" bIns="36576"/>
+          <a:bodyPr wrap="square" lIns="73152" tIns="36576" rIns="73152" bIns="36576" rtlCol="0" anchor="ctr"/>
           <a:lstStyle/>
           <a:p>
             <a:pPr algn="ctr"/>
@@ -8790,7 +8856,7 @@
       <p:sp>
         <p:nvSpPr>
           <p:cNvPr id="8" name="Rounded Rectangle 7">
-            <a:hlinkClick action="ppaction://hlinksldjump" r:id="rId5"/>
+            <a:hlinkClick r:id="rId5" action="ppaction://hlinksldjump"/>
           </p:cNvPr>
           <p:cNvSpPr/>
           <p:nvPr/>
@@ -8825,7 +8891,7 @@
           </a:fontRef>
         </p:style>
         <p:txBody>
-          <a:bodyPr rtlCol="0" anchor="ctr" wrap="square" lIns="73152" rIns="73152" tIns="36576" bIns="36576"/>
+          <a:bodyPr wrap="square" lIns="73152" tIns="36576" rIns="73152" bIns="36576" rtlCol="0" anchor="ctr"/>
           <a:lstStyle/>
           <a:p>
             <a:pPr algn="ctr"/>
@@ -8844,7 +8910,7 @@
       <p:sp>
         <p:nvSpPr>
           <p:cNvPr id="9" name="Rounded Rectangle 8">
-            <a:hlinkClick action="ppaction://hlinksldjump" r:id="rId6"/>
+            <a:hlinkClick r:id="rId6" action="ppaction://hlinksldjump"/>
           </p:cNvPr>
           <p:cNvSpPr/>
           <p:nvPr/>
@@ -8879,7 +8945,7 @@
           </a:fontRef>
         </p:style>
         <p:txBody>
-          <a:bodyPr rtlCol="0" anchor="ctr" wrap="square" lIns="73152" rIns="73152" tIns="36576" bIns="36576"/>
+          <a:bodyPr wrap="square" lIns="73152" tIns="36576" rIns="73152" bIns="36576" rtlCol="0" anchor="ctr"/>
           <a:lstStyle/>
           <a:p>
             <a:pPr algn="ctr"/>
@@ -8898,7 +8964,7 @@
       <p:sp>
         <p:nvSpPr>
           <p:cNvPr id="10" name="Rounded Rectangle 9">
-            <a:hlinkClick action="ppaction://hlinksldjump" r:id="rId7"/>
+            <a:hlinkClick r:id="rId7" action="ppaction://hlinksldjump"/>
           </p:cNvPr>
           <p:cNvSpPr/>
           <p:nvPr/>
@@ -8933,7 +8999,7 @@
           </a:fontRef>
         </p:style>
         <p:txBody>
-          <a:bodyPr rtlCol="0" anchor="ctr" wrap="square" lIns="73152" rIns="73152" tIns="36576" bIns="36576"/>
+          <a:bodyPr wrap="square" lIns="73152" tIns="36576" rIns="73152" bIns="36576" rtlCol="0" anchor="ctr"/>
           <a:lstStyle/>
           <a:p>
             <a:pPr algn="ctr"/>
@@ -8952,7 +9018,7 @@
       <p:sp>
         <p:nvSpPr>
           <p:cNvPr id="11" name="Rounded Rectangle 10">
-            <a:hlinkClick action="ppaction://hlinksldjump" r:id="rId8"/>
+            <a:hlinkClick r:id="rId8" action="ppaction://hlinksldjump"/>
           </p:cNvPr>
           <p:cNvSpPr/>
           <p:nvPr/>
@@ -8987,7 +9053,7 @@
           </a:fontRef>
         </p:style>
         <p:txBody>
-          <a:bodyPr rtlCol="0" anchor="ctr" wrap="square" lIns="73152" rIns="73152" tIns="36576" bIns="36576"/>
+          <a:bodyPr wrap="square" lIns="73152" tIns="36576" rIns="73152" bIns="36576" rtlCol="0" anchor="ctr"/>
           <a:lstStyle/>
           <a:p>
             <a:pPr algn="ctr"/>
@@ -9006,7 +9072,7 @@
       <p:sp>
         <p:nvSpPr>
           <p:cNvPr id="12" name="Rounded Rectangle 11">
-            <a:hlinkClick action="ppaction://hlinksldjump" r:id="rId9"/>
+            <a:hlinkClick r:id="rId9" action="ppaction://hlinksldjump"/>
           </p:cNvPr>
           <p:cNvSpPr/>
           <p:nvPr/>
@@ -9041,7 +9107,7 @@
           </a:fontRef>
         </p:style>
         <p:txBody>
-          <a:bodyPr rtlCol="0" anchor="ctr" wrap="square" lIns="73152" rIns="73152" tIns="36576" bIns="36576"/>
+          <a:bodyPr wrap="square" lIns="73152" tIns="36576" rIns="73152" bIns="36576" rtlCol="0" anchor="ctr"/>
           <a:lstStyle/>
           <a:p>
             <a:pPr algn="ctr"/>
@@ -9060,7 +9126,7 @@
       <p:sp>
         <p:nvSpPr>
           <p:cNvPr id="13" name="Rounded Rectangle 12">
-            <a:hlinkClick action="ppaction://hlinksldjump" r:id="rId10"/>
+            <a:hlinkClick r:id="rId10" action="ppaction://hlinksldjump"/>
           </p:cNvPr>
           <p:cNvSpPr/>
           <p:nvPr/>
@@ -9095,7 +9161,7 @@
           </a:fontRef>
         </p:style>
         <p:txBody>
-          <a:bodyPr rtlCol="0" anchor="ctr" wrap="square" lIns="73152" rIns="73152" tIns="36576" bIns="36576"/>
+          <a:bodyPr wrap="square" lIns="73152" tIns="36576" rIns="73152" bIns="36576" rtlCol="0" anchor="ctr"/>
           <a:lstStyle/>
           <a:p>
             <a:pPr algn="ctr"/>
@@ -9153,6 +9219,7 @@
           <a:lstStyle/>
           <a:p>
             <a:pPr algn="ctr"/>
+            <a:endParaRPr/>
           </a:p>
         </p:txBody>
       </p:sp>
@@ -9246,6 +9313,7 @@
           <a:lstStyle/>
           <a:p>
             <a:pPr algn="ctr"/>
+            <a:endParaRPr/>
           </a:p>
         </p:txBody>
       </p:sp>
@@ -9321,7 +9389,7 @@
       <p:sp>
         <p:nvSpPr>
           <p:cNvPr id="20" name="Rounded Rectangle 19">
-            <a:hlinkClick action="ppaction://hlinksldjump" r:id="rId4"/>
+            <a:hlinkClick r:id="rId4" action="ppaction://hlinksldjump"/>
           </p:cNvPr>
           <p:cNvSpPr/>
           <p:nvPr/>
@@ -9358,7 +9426,7 @@
           </a:fontRef>
         </p:style>
         <p:txBody>
-          <a:bodyPr rtlCol="0" anchor="ctr" wrap="square" lIns="73152" rIns="73152" tIns="36576" bIns="36576"/>
+          <a:bodyPr wrap="square" lIns="73152" tIns="36576" rIns="73152" bIns="36576" rtlCol="0" anchor="ctr"/>
           <a:lstStyle/>
           <a:p>
             <a:pPr algn="ctr"/>
@@ -9377,7 +9445,7 @@
       <p:sp>
         <p:nvSpPr>
           <p:cNvPr id="21" name="Rounded Rectangle 20">
-            <a:hlinkClick action="ppaction://hlinksldjump" r:id="rId5"/>
+            <a:hlinkClick r:id="rId5" action="ppaction://hlinksldjump"/>
           </p:cNvPr>
           <p:cNvSpPr/>
           <p:nvPr/>
@@ -9412,7 +9480,7 @@
           </a:fontRef>
         </p:style>
         <p:txBody>
-          <a:bodyPr rtlCol="0" anchor="ctr" wrap="square" lIns="73152" rIns="73152" tIns="36576" bIns="36576"/>
+          <a:bodyPr wrap="square" lIns="73152" tIns="36576" rIns="73152" bIns="36576" rtlCol="0" anchor="ctr"/>
           <a:lstStyle/>
           <a:p>
             <a:pPr algn="ctr"/>
@@ -9470,6 +9538,7 @@
           <a:lstStyle/>
           <a:p>
             <a:pPr algn="ctr"/>
+            <a:endParaRPr/>
           </a:p>
         </p:txBody>
       </p:sp>
@@ -9559,6 +9628,7 @@
           <a:lstStyle/>
           <a:p>
             <a:pPr algn="ctr"/>
+            <a:endParaRPr/>
           </a:p>
         </p:txBody>
       </p:sp>
@@ -9602,6 +9672,7 @@
           <a:lstStyle/>
           <a:p>
             <a:pPr algn="ctr"/>
+            <a:endParaRPr/>
           </a:p>
         </p:txBody>
       </p:sp>
@@ -9705,6 +9776,7 @@
           <a:lstStyle/>
           <a:p>
             <a:pPr algn="ctr"/>
+            <a:endParaRPr/>
           </a:p>
         </p:txBody>
       </p:sp>
@@ -9748,6 +9820,7 @@
           <a:lstStyle/>
           <a:p>
             <a:pPr algn="ctr"/>
+            <a:endParaRPr/>
           </a:p>
         </p:txBody>
       </p:sp>
@@ -9851,6 +9924,7 @@
           <a:lstStyle/>
           <a:p>
             <a:pPr algn="ctr"/>
+            <a:endParaRPr/>
           </a:p>
         </p:txBody>
       </p:sp>
@@ -9894,6 +9968,7 @@
           <a:lstStyle/>
           <a:p>
             <a:pPr algn="ctr"/>
+            <a:endParaRPr/>
           </a:p>
         </p:txBody>
       </p:sp>
@@ -9997,6 +10072,7 @@
           <a:lstStyle/>
           <a:p>
             <a:pPr algn="ctr"/>
+            <a:endParaRPr/>
           </a:p>
         </p:txBody>
       </p:sp>
@@ -10040,6 +10116,7 @@
           <a:lstStyle/>
           <a:p>
             <a:pPr algn="ctr"/>
+            <a:endParaRPr/>
           </a:p>
         </p:txBody>
       </p:sp>
@@ -10104,7 +10181,7 @@
       <p:sp>
         <p:nvSpPr>
           <p:cNvPr id="36" name="Rounded Rectangle 35">
-            <a:hlinkClick action="ppaction://hlinksldjump" r:id="rId5"/>
+            <a:hlinkClick r:id="rId5" action="ppaction://hlinksldjump"/>
           </p:cNvPr>
           <p:cNvSpPr/>
           <p:nvPr/>
@@ -10139,7 +10216,7 @@
           </a:fontRef>
         </p:style>
         <p:txBody>
-          <a:bodyPr rtlCol="0" anchor="ctr" wrap="square" lIns="73152" rIns="73152" tIns="36576" bIns="36576"/>
+          <a:bodyPr wrap="square" lIns="73152" tIns="36576" rIns="73152" bIns="36576" rtlCol="0" anchor="ctr"/>
           <a:lstStyle/>
           <a:p>
             <a:pPr algn="ctr"/>
@@ -10151,6 +10228,122 @@
                 <a:latin typeface="Segoe UI"/>
               </a:rPr>
               <a:t>👉 See Our Solution (CompliScan AI)</a:t>
+            </a:r>
+          </a:p>
+        </p:txBody>
+      </p:sp>
+      <p:sp>
+        <p:nvSpPr>
+          <p:cNvPr id="37" name="Rounded Rectangle 16">
+            <a:extLst>
+              <a:ext uri="{FF2B5EF4-FFF2-40B4-BE49-F238E27FC236}">
+                <a16:creationId xmlns:a16="http://schemas.microsoft.com/office/drawing/2014/main" id="{CB9685C7-6310-8490-A564-859DEBB328F2}"/>
+              </a:ext>
+            </a:extLst>
+          </p:cNvPr>
+          <p:cNvSpPr/>
+          <p:nvPr/>
+        </p:nvSpPr>
+        <p:spPr>
+          <a:xfrm>
+            <a:off x="457200" y="6263641"/>
+            <a:ext cx="11277295" cy="411480"/>
+          </a:xfrm>
+          <a:prstGeom prst="roundRect">
+            <a:avLst/>
+          </a:prstGeom>
+          <a:solidFill>
+            <a:srgbClr val="FFFFFF"/>
+          </a:solidFill>
+          <a:ln w="12700">
+            <a:solidFill>
+              <a:srgbClr val="E2E8F0"/>
+            </a:solidFill>
+          </a:ln>
+        </p:spPr>
+        <p:style>
+          <a:lnRef idx="1">
+            <a:schemeClr val="accent1"/>
+          </a:lnRef>
+          <a:fillRef idx="3">
+            <a:schemeClr val="accent1"/>
+          </a:fillRef>
+          <a:effectRef idx="2">
+            <a:schemeClr val="accent1"/>
+          </a:effectRef>
+          <a:fontRef idx="minor">
+            <a:schemeClr val="lt1"/>
+          </a:fontRef>
+        </p:style>
+        <p:txBody>
+          <a:bodyPr rtlCol="0" anchor="ctr"/>
+          <a:lstStyle/>
+          <a:p>
+            <a:pPr algn="ctr"/>
+            <a:endParaRPr/>
+          </a:p>
+        </p:txBody>
+      </p:sp>
+      <p:sp>
+        <p:nvSpPr>
+          <p:cNvPr id="38" name="TextBox 37">
+            <a:extLst>
+              <a:ext uri="{FF2B5EF4-FFF2-40B4-BE49-F238E27FC236}">
+                <a16:creationId xmlns:a16="http://schemas.microsoft.com/office/drawing/2014/main" id="{29E17AB9-820F-BAF4-A404-0A048FE7FD12}"/>
+              </a:ext>
+            </a:extLst>
+          </p:cNvPr>
+          <p:cNvSpPr txBox="1"/>
+          <p:nvPr/>
+        </p:nvSpPr>
+        <p:spPr>
+          <a:xfrm>
+            <a:off x="6446520" y="2103121"/>
+            <a:ext cx="5120640" cy="1554480"/>
+          </a:xfrm>
+          <a:prstGeom prst="rect">
+            <a:avLst/>
+          </a:prstGeom>
+          <a:noFill/>
+        </p:spPr>
+        <p:txBody>
+          <a:bodyPr wrap="square">
+            <a:spAutoFit/>
+          </a:bodyPr>
+          <a:lstStyle/>
+          <a:p>
+            <a:r>
+              <a:rPr sz="1250" b="1">
+                <a:solidFill>
+                  <a:srgbClr val="EF4444"/>
+                </a:solidFill>
+                <a:latin typeface="Segoe UI"/>
+              </a:rPr>
+              <a:t>2. Enforcement Inspection Bottleneck
+</a:t>
+            </a:r>
+          </a:p>
+          <a:p>
+            <a:r>
+              <a:rPr sz="950">
+                <a:solidFill>
+                  <a:srgbClr val="0F172A"/>
+                </a:solidFill>
+                <a:latin typeface="Segoe UI"/>
+              </a:rPr>
+              <a:t>Manual retail inspections by enforcement officers are time-consuming and cover less than 1% of products in circulating markets.
+</a:t>
+            </a:r>
+          </a:p>
+          <a:p>
+            <a:r>
+              <a:rPr sz="900" b="1">
+                <a:solidFill>
+                  <a:srgbClr val="EF4444"/>
+                </a:solidFill>
+                <a:latin typeface="Segoe UI"/>
+              </a:rPr>
+              <a:t>❌ Physical spot-audits cannot scale across 100M+ retail SKUs.</a:t>
             </a:r>
           </a:p>
         </p:txBody>
@@ -10164,7 +10357,7 @@
 </file>
 
 <file path=ppt/slides/slide3.xml><?xml version="1.0" encoding="utf-8"?>
-<p:sld xmlns:a="http://schemas.openxmlformats.org/drawingml/2006/main" xmlns:p="http://schemas.openxmlformats.org/presentationml/2006/main" xmlns:r="http://schemas.openxmlformats.org/officeDocument/2006/relationships">
+<p:sld xmlns:a="http://schemas.openxmlformats.org/drawingml/2006/main" xmlns:r="http://schemas.openxmlformats.org/officeDocument/2006/relationships" xmlns:p="http://schemas.openxmlformats.org/presentationml/2006/main">
   <p:cSld>
     <p:spTree>
       <p:nvGrpSpPr>
@@ -10172,7 +10365,14 @@
         <p:cNvGrpSpPr/>
         <p:nvPr/>
       </p:nvGrpSpPr>
-      <p:grpSpPr/>
+      <p:grpSpPr>
+        <a:xfrm>
+          <a:off x="0" y="0"/>
+          <a:ext cx="0" cy="0"/>
+          <a:chOff x="0" y="0"/>
+          <a:chExt cx="0" cy="0"/>
+        </a:xfrm>
+      </p:grpSpPr>
       <p:sp>
         <p:nvSpPr>
           <p:cNvPr id="2" name="Rectangle 1"/>
@@ -10213,6 +10413,7 @@
           <a:lstStyle/>
           <a:p>
             <a:pPr algn="ctr"/>
+            <a:endParaRPr/>
           </a:p>
         </p:txBody>
       </p:sp>
@@ -10282,6 +10483,7 @@
           <a:lstStyle/>
           <a:p>
             <a:pPr algn="ctr"/>
+            <a:endParaRPr/>
           </a:p>
         </p:txBody>
       </p:sp>
@@ -10332,7 +10534,7 @@
           <a:lstStyle/>
           <a:p>
             <a:r>
-              <a:rPr b="1" sz="1300">
+              <a:rPr sz="1300" b="1">
                 <a:solidFill>
                   <a:srgbClr val="4F46E5"/>
                 </a:solidFill>
@@ -10341,7 +10543,7 @@
               <a:t>CompliScan </a:t>
             </a:r>
             <a:r>
-              <a:rPr b="1" sz="1300">
+              <a:rPr sz="1300" b="1">
                 <a:solidFill>
                   <a:srgbClr val="10B981"/>
                 </a:solidFill>
@@ -10366,7 +10568,7 @@
       <p:sp>
         <p:nvSpPr>
           <p:cNvPr id="7" name="Rounded Rectangle 6">
-            <a:hlinkClick action="ppaction://hlinksldjump" r:id="rId4"/>
+            <a:hlinkClick r:id="rId4" action="ppaction://hlinksldjump"/>
           </p:cNvPr>
           <p:cNvSpPr/>
           <p:nvPr/>
@@ -10401,7 +10603,7 @@
           </a:fontRef>
         </p:style>
         <p:txBody>
-          <a:bodyPr rtlCol="0" anchor="ctr" wrap="square" lIns="73152" rIns="73152" tIns="36576" bIns="36576"/>
+          <a:bodyPr wrap="square" lIns="73152" tIns="36576" rIns="73152" bIns="36576" rtlCol="0" anchor="ctr"/>
           <a:lstStyle/>
           <a:p>
             <a:pPr algn="ctr"/>
@@ -10420,7 +10622,7 @@
       <p:sp>
         <p:nvSpPr>
           <p:cNvPr id="8" name="Rounded Rectangle 7">
-            <a:hlinkClick action="ppaction://hlinksldjump" r:id="rId5"/>
+            <a:hlinkClick r:id="rId5" action="ppaction://hlinksldjump"/>
           </p:cNvPr>
           <p:cNvSpPr/>
           <p:nvPr/>
@@ -10455,7 +10657,7 @@
           </a:fontRef>
         </p:style>
         <p:txBody>
-          <a:bodyPr rtlCol="0" anchor="ctr" wrap="square" lIns="73152" rIns="73152" tIns="36576" bIns="36576"/>
+          <a:bodyPr wrap="square" lIns="73152" tIns="36576" rIns="73152" bIns="36576" rtlCol="0" anchor="ctr"/>
           <a:lstStyle/>
           <a:p>
             <a:pPr algn="ctr"/>
@@ -10474,7 +10676,7 @@
       <p:sp>
         <p:nvSpPr>
           <p:cNvPr id="9" name="Rounded Rectangle 8">
-            <a:hlinkClick action="ppaction://hlinksldjump" r:id="rId6"/>
+            <a:hlinkClick r:id="rId6" action="ppaction://hlinksldjump"/>
           </p:cNvPr>
           <p:cNvSpPr/>
           <p:nvPr/>
@@ -10509,7 +10711,7 @@
           </a:fontRef>
         </p:style>
         <p:txBody>
-          <a:bodyPr rtlCol="0" anchor="ctr" wrap="square" lIns="73152" rIns="73152" tIns="36576" bIns="36576"/>
+          <a:bodyPr wrap="square" lIns="73152" tIns="36576" rIns="73152" bIns="36576" rtlCol="0" anchor="ctr"/>
           <a:lstStyle/>
           <a:p>
             <a:pPr algn="ctr"/>
@@ -10528,7 +10730,7 @@
       <p:sp>
         <p:nvSpPr>
           <p:cNvPr id="10" name="Rounded Rectangle 9">
-            <a:hlinkClick action="ppaction://hlinksldjump" r:id="rId7"/>
+            <a:hlinkClick r:id="rId7" action="ppaction://hlinksldjump"/>
           </p:cNvPr>
           <p:cNvSpPr/>
           <p:nvPr/>
@@ -10563,7 +10765,7 @@
           </a:fontRef>
         </p:style>
         <p:txBody>
-          <a:bodyPr rtlCol="0" anchor="ctr" wrap="square" lIns="73152" rIns="73152" tIns="36576" bIns="36576"/>
+          <a:bodyPr wrap="square" lIns="73152" tIns="36576" rIns="73152" bIns="36576" rtlCol="0" anchor="ctr"/>
           <a:lstStyle/>
           <a:p>
             <a:pPr algn="ctr"/>
@@ -10582,7 +10784,7 @@
       <p:sp>
         <p:nvSpPr>
           <p:cNvPr id="11" name="Rounded Rectangle 10">
-            <a:hlinkClick action="ppaction://hlinksldjump" r:id="rId8"/>
+            <a:hlinkClick r:id="rId8" action="ppaction://hlinksldjump"/>
           </p:cNvPr>
           <p:cNvSpPr/>
           <p:nvPr/>
@@ -10617,7 +10819,7 @@
           </a:fontRef>
         </p:style>
         <p:txBody>
-          <a:bodyPr rtlCol="0" anchor="ctr" wrap="square" lIns="73152" rIns="73152" tIns="36576" bIns="36576"/>
+          <a:bodyPr wrap="square" lIns="73152" tIns="36576" rIns="73152" bIns="36576" rtlCol="0" anchor="ctr"/>
           <a:lstStyle/>
           <a:p>
             <a:pPr algn="ctr"/>
@@ -10636,7 +10838,7 @@
       <p:sp>
         <p:nvSpPr>
           <p:cNvPr id="12" name="Rounded Rectangle 11">
-            <a:hlinkClick action="ppaction://hlinksldjump" r:id="rId9"/>
+            <a:hlinkClick r:id="rId9" action="ppaction://hlinksldjump"/>
           </p:cNvPr>
           <p:cNvSpPr/>
           <p:nvPr/>
@@ -10671,7 +10873,7 @@
           </a:fontRef>
         </p:style>
         <p:txBody>
-          <a:bodyPr rtlCol="0" anchor="ctr" wrap="square" lIns="73152" rIns="73152" tIns="36576" bIns="36576"/>
+          <a:bodyPr wrap="square" lIns="73152" tIns="36576" rIns="73152" bIns="36576" rtlCol="0" anchor="ctr"/>
           <a:lstStyle/>
           <a:p>
             <a:pPr algn="ctr"/>
@@ -10690,7 +10892,7 @@
       <p:sp>
         <p:nvSpPr>
           <p:cNvPr id="13" name="Rounded Rectangle 12">
-            <a:hlinkClick action="ppaction://hlinksldjump" r:id="rId10"/>
+            <a:hlinkClick r:id="rId10" action="ppaction://hlinksldjump"/>
           </p:cNvPr>
           <p:cNvSpPr/>
           <p:nvPr/>
@@ -10725,7 +10927,7 @@
           </a:fontRef>
         </p:style>
         <p:txBody>
-          <a:bodyPr rtlCol="0" anchor="ctr" wrap="square" lIns="73152" rIns="73152" tIns="36576" bIns="36576"/>
+          <a:bodyPr wrap="square" lIns="73152" tIns="36576" rIns="73152" bIns="36576" rtlCol="0" anchor="ctr"/>
           <a:lstStyle/>
           <a:p>
             <a:pPr algn="ctr"/>
@@ -10783,6 +10985,7 @@
           <a:lstStyle/>
           <a:p>
             <a:pPr algn="ctr"/>
+            <a:endParaRPr/>
           </a:p>
         </p:txBody>
       </p:sp>
@@ -10876,6 +11079,7 @@
           <a:lstStyle/>
           <a:p>
             <a:pPr algn="ctr"/>
+            <a:endParaRPr/>
           </a:p>
         </p:txBody>
       </p:sp>
@@ -10951,7 +11155,7 @@
       <p:sp>
         <p:nvSpPr>
           <p:cNvPr id="20" name="Rounded Rectangle 19">
-            <a:hlinkClick action="ppaction://hlinksldjump" r:id="rId13"/>
+            <a:hlinkClick r:id="rId13" action="ppaction://hlinksldjump"/>
           </p:cNvPr>
           <p:cNvSpPr/>
           <p:nvPr/>
@@ -10988,7 +11192,7 @@
           </a:fontRef>
         </p:style>
         <p:txBody>
-          <a:bodyPr rtlCol="0" anchor="ctr" wrap="square" lIns="73152" rIns="73152" tIns="36576" bIns="36576"/>
+          <a:bodyPr wrap="square" lIns="73152" tIns="36576" rIns="73152" bIns="36576" rtlCol="0" anchor="ctr"/>
           <a:lstStyle/>
           <a:p>
             <a:pPr algn="ctr"/>
@@ -11007,7 +11211,7 @@
       <p:sp>
         <p:nvSpPr>
           <p:cNvPr id="21" name="Rounded Rectangle 20">
-            <a:hlinkClick action="ppaction://hlinksldjump" r:id="rId6"/>
+            <a:hlinkClick r:id="rId6" action="ppaction://hlinksldjump"/>
           </p:cNvPr>
           <p:cNvSpPr/>
           <p:nvPr/>
@@ -11042,7 +11246,7 @@
           </a:fontRef>
         </p:style>
         <p:txBody>
-          <a:bodyPr rtlCol="0" anchor="ctr" wrap="square" lIns="73152" rIns="73152" tIns="36576" bIns="36576"/>
+          <a:bodyPr wrap="square" lIns="73152" tIns="36576" rIns="73152" bIns="36576" rtlCol="0" anchor="ctr"/>
           <a:lstStyle/>
           <a:p>
             <a:pPr algn="ctr"/>
@@ -11100,6 +11304,7 @@
           <a:lstStyle/>
           <a:p>
             <a:pPr algn="ctr"/>
+            <a:endParaRPr/>
           </a:p>
         </p:txBody>
       </p:sp>
@@ -11180,6 +11385,7 @@
           <a:lstStyle/>
           <a:p>
             <a:pPr algn="ctr"/>
+            <a:endParaRPr/>
           </a:p>
         </p:txBody>
       </p:sp>
@@ -11206,7 +11412,7 @@
           <a:lstStyle/>
           <a:p>
             <a:r>
-              <a:rPr sz="1050" b="1">
+              <a:rPr sz="1050" b="1" dirty="0">
                 <a:solidFill>
                   <a:srgbClr val="0F172A"/>
                 </a:solidFill>
@@ -11218,7 +11424,7 @@
           </a:p>
           <a:p>
             <a:r>
-              <a:rPr sz="850">
+              <a:rPr sz="850" dirty="0">
                 <a:solidFill>
                   <a:srgbClr val="64748B"/>
                 </a:solidFill>
@@ -11271,6 +11477,7 @@
           <a:lstStyle/>
           <a:p>
             <a:pPr algn="ctr"/>
+            <a:endParaRPr/>
           </a:p>
         </p:txBody>
       </p:sp>
@@ -11362,6 +11569,7 @@
           <a:lstStyle/>
           <a:p>
             <a:pPr algn="ctr"/>
+            <a:endParaRPr/>
           </a:p>
         </p:txBody>
       </p:sp>
@@ -11453,6 +11661,7 @@
           <a:lstStyle/>
           <a:p>
             <a:pPr algn="ctr"/>
+            <a:endParaRPr/>
           </a:p>
         </p:txBody>
       </p:sp>
@@ -11544,6 +11753,7 @@
           <a:lstStyle/>
           <a:p>
             <a:pPr algn="ctr"/>
+            <a:endParaRPr/>
           </a:p>
         </p:txBody>
       </p:sp>
@@ -11635,6 +11845,7 @@
           <a:lstStyle/>
           <a:p>
             <a:pPr algn="ctr"/>
+            <a:endParaRPr/>
           </a:p>
         </p:txBody>
       </p:sp>
@@ -11726,6 +11937,7 @@
           <a:lstStyle/>
           <a:p>
             <a:pPr algn="ctr"/>
+            <a:endParaRPr/>
           </a:p>
         </p:txBody>
       </p:sp>
@@ -11817,6 +12029,7 @@
           <a:lstStyle/>
           <a:p>
             <a:pPr algn="ctr"/>
+            <a:endParaRPr/>
           </a:p>
         </p:txBody>
       </p:sp>
@@ -11908,6 +12121,7 @@
           <a:lstStyle/>
           <a:p>
             <a:pPr algn="ctr"/>
+            <a:endParaRPr/>
           </a:p>
         </p:txBody>
       </p:sp>
@@ -11960,7 +12174,7 @@
       <p:sp>
         <p:nvSpPr>
           <p:cNvPr id="42" name="Rounded Rectangle 41">
-            <a:hlinkClick action="ppaction://hlinksldjump" r:id="rId6"/>
+            <a:hlinkClick r:id="rId6" action="ppaction://hlinksldjump"/>
           </p:cNvPr>
           <p:cNvSpPr/>
           <p:nvPr/>
@@ -11995,7 +12209,7 @@
           </a:fontRef>
         </p:style>
         <p:txBody>
-          <a:bodyPr rtlCol="0" anchor="ctr" wrap="square" lIns="73152" rIns="73152" tIns="36576" bIns="36576"/>
+          <a:bodyPr wrap="square" lIns="73152" tIns="36576" rIns="73152" bIns="36576" rtlCol="0" anchor="ctr"/>
           <a:lstStyle/>
           <a:p>
             <a:pPr algn="ctr"/>
@@ -12020,7 +12234,7 @@
 </file>
 
 <file path=ppt/slides/slide4.xml><?xml version="1.0" encoding="utf-8"?>
-<p:sld xmlns:a="http://schemas.openxmlformats.org/drawingml/2006/main" xmlns:p="http://schemas.openxmlformats.org/presentationml/2006/main" xmlns:r="http://schemas.openxmlformats.org/officeDocument/2006/relationships">
+<p:sld xmlns:a="http://schemas.openxmlformats.org/drawingml/2006/main" xmlns:r="http://schemas.openxmlformats.org/officeDocument/2006/relationships" xmlns:p="http://schemas.openxmlformats.org/presentationml/2006/main">
   <p:cSld>
     <p:spTree>
       <p:nvGrpSpPr>
@@ -12028,7 +12242,14 @@
         <p:cNvGrpSpPr/>
         <p:nvPr/>
       </p:nvGrpSpPr>
-      <p:grpSpPr/>
+      <p:grpSpPr>
+        <a:xfrm>
+          <a:off x="0" y="0"/>
+          <a:ext cx="0" cy="0"/>
+          <a:chOff x="0" y="0"/>
+          <a:chExt cx="0" cy="0"/>
+        </a:xfrm>
+      </p:grpSpPr>
       <p:sp>
         <p:nvSpPr>
           <p:cNvPr id="2" name="Rectangle 1"/>
@@ -12069,6 +12290,7 @@
           <a:lstStyle/>
           <a:p>
             <a:pPr algn="ctr"/>
+            <a:endParaRPr/>
           </a:p>
         </p:txBody>
       </p:sp>
@@ -12138,6 +12360,7 @@
           <a:lstStyle/>
           <a:p>
             <a:pPr algn="ctr"/>
+            <a:endParaRPr/>
           </a:p>
         </p:txBody>
       </p:sp>
@@ -12188,7 +12411,7 @@
           <a:lstStyle/>
           <a:p>
             <a:r>
-              <a:rPr b="1" sz="1300">
+              <a:rPr sz="1300" b="1">
                 <a:solidFill>
                   <a:srgbClr val="4F46E5"/>
                 </a:solidFill>
@@ -12197,7 +12420,7 @@
               <a:t>CompliScan </a:t>
             </a:r>
             <a:r>
-              <a:rPr b="1" sz="1300">
+              <a:rPr sz="1300" b="1">
                 <a:solidFill>
                   <a:srgbClr val="10B981"/>
                 </a:solidFill>
@@ -12222,7 +12445,7 @@
       <p:sp>
         <p:nvSpPr>
           <p:cNvPr id="7" name="Rounded Rectangle 6">
-            <a:hlinkClick action="ppaction://hlinksldjump" r:id="rId4"/>
+            <a:hlinkClick r:id="rId4" action="ppaction://hlinksldjump"/>
           </p:cNvPr>
           <p:cNvSpPr/>
           <p:nvPr/>
@@ -12257,7 +12480,7 @@
           </a:fontRef>
         </p:style>
         <p:txBody>
-          <a:bodyPr rtlCol="0" anchor="ctr" wrap="square" lIns="73152" rIns="73152" tIns="36576" bIns="36576"/>
+          <a:bodyPr wrap="square" lIns="73152" tIns="36576" rIns="73152" bIns="36576" rtlCol="0" anchor="ctr"/>
           <a:lstStyle/>
           <a:p>
             <a:pPr algn="ctr"/>
@@ -12276,7 +12499,7 @@
       <p:sp>
         <p:nvSpPr>
           <p:cNvPr id="8" name="Rounded Rectangle 7">
-            <a:hlinkClick action="ppaction://hlinksldjump" r:id="rId5"/>
+            <a:hlinkClick r:id="rId5" action="ppaction://hlinksldjump"/>
           </p:cNvPr>
           <p:cNvSpPr/>
           <p:nvPr/>
@@ -12311,7 +12534,7 @@
           </a:fontRef>
         </p:style>
         <p:txBody>
-          <a:bodyPr rtlCol="0" anchor="ctr" wrap="square" lIns="73152" rIns="73152" tIns="36576" bIns="36576"/>
+          <a:bodyPr wrap="square" lIns="73152" tIns="36576" rIns="73152" bIns="36576" rtlCol="0" anchor="ctr"/>
           <a:lstStyle/>
           <a:p>
             <a:pPr algn="ctr"/>
@@ -12330,7 +12553,7 @@
       <p:sp>
         <p:nvSpPr>
           <p:cNvPr id="9" name="Rounded Rectangle 8">
-            <a:hlinkClick action="ppaction://hlinksldjump" r:id="rId6"/>
+            <a:hlinkClick r:id="rId6" action="ppaction://hlinksldjump"/>
           </p:cNvPr>
           <p:cNvSpPr/>
           <p:nvPr/>
@@ -12365,7 +12588,7 @@
           </a:fontRef>
         </p:style>
         <p:txBody>
-          <a:bodyPr rtlCol="0" anchor="ctr" wrap="square" lIns="73152" rIns="73152" tIns="36576" bIns="36576"/>
+          <a:bodyPr wrap="square" lIns="73152" tIns="36576" rIns="73152" bIns="36576" rtlCol="0" anchor="ctr"/>
           <a:lstStyle/>
           <a:p>
             <a:pPr algn="ctr"/>
@@ -12384,7 +12607,7 @@
       <p:sp>
         <p:nvSpPr>
           <p:cNvPr id="10" name="Rounded Rectangle 9">
-            <a:hlinkClick action="ppaction://hlinksldjump" r:id="rId7"/>
+            <a:hlinkClick r:id="rId7" action="ppaction://hlinksldjump"/>
           </p:cNvPr>
           <p:cNvSpPr/>
           <p:nvPr/>
@@ -12419,7 +12642,7 @@
           </a:fontRef>
         </p:style>
         <p:txBody>
-          <a:bodyPr rtlCol="0" anchor="ctr" wrap="square" lIns="73152" rIns="73152" tIns="36576" bIns="36576"/>
+          <a:bodyPr wrap="square" lIns="73152" tIns="36576" rIns="73152" bIns="36576" rtlCol="0" anchor="ctr"/>
           <a:lstStyle/>
           <a:p>
             <a:pPr algn="ctr"/>
@@ -12438,7 +12661,7 @@
       <p:sp>
         <p:nvSpPr>
           <p:cNvPr id="11" name="Rounded Rectangle 10">
-            <a:hlinkClick action="ppaction://hlinksldjump" r:id="rId8"/>
+            <a:hlinkClick r:id="rId8" action="ppaction://hlinksldjump"/>
           </p:cNvPr>
           <p:cNvSpPr/>
           <p:nvPr/>
@@ -12473,7 +12696,7 @@
           </a:fontRef>
         </p:style>
         <p:txBody>
-          <a:bodyPr rtlCol="0" anchor="ctr" wrap="square" lIns="73152" rIns="73152" tIns="36576" bIns="36576"/>
+          <a:bodyPr wrap="square" lIns="73152" tIns="36576" rIns="73152" bIns="36576" rtlCol="0" anchor="ctr"/>
           <a:lstStyle/>
           <a:p>
             <a:pPr algn="ctr"/>
@@ -12492,7 +12715,7 @@
       <p:sp>
         <p:nvSpPr>
           <p:cNvPr id="12" name="Rounded Rectangle 11">
-            <a:hlinkClick action="ppaction://hlinksldjump" r:id="rId9"/>
+            <a:hlinkClick r:id="rId9" action="ppaction://hlinksldjump"/>
           </p:cNvPr>
           <p:cNvSpPr/>
           <p:nvPr/>
@@ -12527,7 +12750,7 @@
           </a:fontRef>
         </p:style>
         <p:txBody>
-          <a:bodyPr rtlCol="0" anchor="ctr" wrap="square" lIns="73152" rIns="73152" tIns="36576" bIns="36576"/>
+          <a:bodyPr wrap="square" lIns="73152" tIns="36576" rIns="73152" bIns="36576" rtlCol="0" anchor="ctr"/>
           <a:lstStyle/>
           <a:p>
             <a:pPr algn="ctr"/>
@@ -12546,7 +12769,7 @@
       <p:sp>
         <p:nvSpPr>
           <p:cNvPr id="13" name="Rounded Rectangle 12">
-            <a:hlinkClick action="ppaction://hlinksldjump" r:id="rId10"/>
+            <a:hlinkClick r:id="rId10" action="ppaction://hlinksldjump"/>
           </p:cNvPr>
           <p:cNvSpPr/>
           <p:nvPr/>
@@ -12581,7 +12804,7 @@
           </a:fontRef>
         </p:style>
         <p:txBody>
-          <a:bodyPr rtlCol="0" anchor="ctr" wrap="square" lIns="73152" rIns="73152" tIns="36576" bIns="36576"/>
+          <a:bodyPr wrap="square" lIns="73152" tIns="36576" rIns="73152" bIns="36576" rtlCol="0" anchor="ctr"/>
           <a:lstStyle/>
           <a:p>
             <a:pPr algn="ctr"/>
@@ -12639,6 +12862,7 @@
           <a:lstStyle/>
           <a:p>
             <a:pPr algn="ctr"/>
+            <a:endParaRPr/>
           </a:p>
         </p:txBody>
       </p:sp>
@@ -12732,6 +12956,7 @@
           <a:lstStyle/>
           <a:p>
             <a:pPr algn="ctr"/>
+            <a:endParaRPr/>
           </a:p>
         </p:txBody>
       </p:sp>
@@ -12807,7 +13032,7 @@
       <p:sp>
         <p:nvSpPr>
           <p:cNvPr id="20" name="Rounded Rectangle 19">
-            <a:hlinkClick action="ppaction://hlinksldjump" r:id="rId5"/>
+            <a:hlinkClick r:id="rId5" action="ppaction://hlinksldjump"/>
           </p:cNvPr>
           <p:cNvSpPr/>
           <p:nvPr/>
@@ -12844,7 +13069,7 @@
           </a:fontRef>
         </p:style>
         <p:txBody>
-          <a:bodyPr rtlCol="0" anchor="ctr" wrap="square" lIns="73152" rIns="73152" tIns="36576" bIns="36576"/>
+          <a:bodyPr wrap="square" lIns="73152" tIns="36576" rIns="73152" bIns="36576" rtlCol="0" anchor="ctr"/>
           <a:lstStyle/>
           <a:p>
             <a:pPr algn="ctr"/>
@@ -12863,7 +13088,7 @@
       <p:sp>
         <p:nvSpPr>
           <p:cNvPr id="21" name="Rounded Rectangle 20">
-            <a:hlinkClick action="ppaction://hlinksldjump" r:id="rId7"/>
+            <a:hlinkClick r:id="rId7" action="ppaction://hlinksldjump"/>
           </p:cNvPr>
           <p:cNvSpPr/>
           <p:nvPr/>
@@ -12898,7 +13123,7 @@
           </a:fontRef>
         </p:style>
         <p:txBody>
-          <a:bodyPr rtlCol="0" anchor="ctr" wrap="square" lIns="73152" rIns="73152" tIns="36576" bIns="36576"/>
+          <a:bodyPr wrap="square" lIns="73152" tIns="36576" rIns="73152" bIns="36576" rtlCol="0" anchor="ctr"/>
           <a:lstStyle/>
           <a:p>
             <a:pPr algn="ctr"/>
@@ -12956,6 +13181,7 @@
           <a:lstStyle/>
           <a:p>
             <a:pPr algn="ctr"/>
+            <a:endParaRPr/>
           </a:p>
         </p:txBody>
       </p:sp>
@@ -13035,6 +13261,7 @@
           <a:lstStyle/>
           <a:p>
             <a:pPr algn="ctr"/>
+            <a:endParaRPr/>
           </a:p>
         </p:txBody>
       </p:sp>
@@ -13080,6 +13307,7 @@
           <a:lstStyle/>
           <a:p>
             <a:pPr algn="ctr"/>
+            <a:endParaRPr/>
           </a:p>
         </p:txBody>
       </p:sp>
@@ -13159,6 +13387,7 @@
           <a:lstStyle/>
           <a:p>
             <a:pPr algn="ctr"/>
+            <a:endParaRPr/>
           </a:p>
         </p:txBody>
       </p:sp>
@@ -13239,6 +13468,7 @@
           <a:lstStyle/>
           <a:p>
             <a:pPr algn="ctr"/>
+            <a:endParaRPr/>
           </a:p>
         </p:txBody>
       </p:sp>
@@ -13319,6 +13549,7 @@
           <a:lstStyle/>
           <a:p>
             <a:pPr algn="ctr"/>
+            <a:endParaRPr/>
           </a:p>
         </p:txBody>
       </p:sp>
@@ -13399,6 +13630,7 @@
           <a:lstStyle/>
           <a:p>
             <a:pPr algn="ctr"/>
+            <a:endParaRPr/>
           </a:p>
         </p:txBody>
       </p:sp>
@@ -13473,7 +13705,7 @@
           </a:fontRef>
         </p:style>
         <p:txBody>
-          <a:bodyPr rtlCol="0" anchor="ctr" wrap="square" lIns="73152" rIns="73152" tIns="36576" bIns="36576"/>
+          <a:bodyPr wrap="square" lIns="73152" tIns="36576" rIns="73152" bIns="36576" rtlCol="0" anchor="ctr"/>
           <a:lstStyle/>
           <a:p>
             <a:pPr algn="ctr"/>
@@ -13531,6 +13763,7 @@
           <a:lstStyle/>
           <a:p>
             <a:pPr algn="ctr"/>
+            <a:endParaRPr/>
           </a:p>
         </p:txBody>
       </p:sp>
@@ -13576,6 +13809,7 @@
           <a:lstStyle/>
           <a:p>
             <a:pPr algn="ctr"/>
+            <a:endParaRPr/>
           </a:p>
         </p:txBody>
       </p:sp>
@@ -13663,6 +13897,7 @@
           <a:lstStyle/>
           <a:p>
             <a:pPr algn="ctr"/>
+            <a:endParaRPr/>
           </a:p>
         </p:txBody>
       </p:sp>
@@ -13720,7 +13955,7 @@
       <p:sp>
         <p:nvSpPr>
           <p:cNvPr id="41" name="Rounded Rectangle 40">
-            <a:hlinkClick action="ppaction://hlinksldjump" r:id="rId7"/>
+            <a:hlinkClick r:id="rId7" action="ppaction://hlinksldjump"/>
           </p:cNvPr>
           <p:cNvSpPr/>
           <p:nvPr/>
@@ -13755,7 +13990,7 @@
           </a:fontRef>
         </p:style>
         <p:txBody>
-          <a:bodyPr rtlCol="0" anchor="ctr" wrap="square" lIns="73152" rIns="73152" tIns="36576" bIns="36576"/>
+          <a:bodyPr wrap="square" lIns="73152" tIns="36576" rIns="73152" bIns="36576" rtlCol="0" anchor="ctr"/>
           <a:lstStyle/>
           <a:p>
             <a:pPr algn="ctr"/>
@@ -13780,7 +14015,7 @@
 </file>
 
 <file path=ppt/slides/slide5.xml><?xml version="1.0" encoding="utf-8"?>
-<p:sld xmlns:a="http://schemas.openxmlformats.org/drawingml/2006/main" xmlns:p="http://schemas.openxmlformats.org/presentationml/2006/main" xmlns:r="http://schemas.openxmlformats.org/officeDocument/2006/relationships">
+<p:sld xmlns:a="http://schemas.openxmlformats.org/drawingml/2006/main" xmlns:r="http://schemas.openxmlformats.org/officeDocument/2006/relationships" xmlns:p="http://schemas.openxmlformats.org/presentationml/2006/main">
   <p:cSld>
     <p:spTree>
       <p:nvGrpSpPr>
@@ -13788,7 +14023,14 @@
         <p:cNvGrpSpPr/>
         <p:nvPr/>
       </p:nvGrpSpPr>
-      <p:grpSpPr/>
+      <p:grpSpPr>
+        <a:xfrm>
+          <a:off x="0" y="0"/>
+          <a:ext cx="0" cy="0"/>
+          <a:chOff x="0" y="0"/>
+          <a:chExt cx="0" cy="0"/>
+        </a:xfrm>
+      </p:grpSpPr>
       <p:sp>
         <p:nvSpPr>
           <p:cNvPr id="2" name="Rectangle 1"/>
@@ -13829,6 +14071,7 @@
           <a:lstStyle/>
           <a:p>
             <a:pPr algn="ctr"/>
+            <a:endParaRPr/>
           </a:p>
         </p:txBody>
       </p:sp>
@@ -13898,6 +14141,7 @@
           <a:lstStyle/>
           <a:p>
             <a:pPr algn="ctr"/>
+            <a:endParaRPr/>
           </a:p>
         </p:txBody>
       </p:sp>
@@ -13948,7 +14192,7 @@
           <a:lstStyle/>
           <a:p>
             <a:r>
-              <a:rPr b="1" sz="1300">
+              <a:rPr sz="1300" b="1">
                 <a:solidFill>
                   <a:srgbClr val="4F46E5"/>
                 </a:solidFill>
@@ -13957,7 +14201,7 @@
               <a:t>CompliScan </a:t>
             </a:r>
             <a:r>
-              <a:rPr b="1" sz="1300">
+              <a:rPr sz="1300" b="1">
                 <a:solidFill>
                   <a:srgbClr val="10B981"/>
                 </a:solidFill>
@@ -13982,7 +14226,7 @@
       <p:sp>
         <p:nvSpPr>
           <p:cNvPr id="7" name="Rounded Rectangle 6">
-            <a:hlinkClick action="ppaction://hlinksldjump" r:id="rId4"/>
+            <a:hlinkClick r:id="rId4" action="ppaction://hlinksldjump"/>
           </p:cNvPr>
           <p:cNvSpPr/>
           <p:nvPr/>
@@ -14017,7 +14261,7 @@
           </a:fontRef>
         </p:style>
         <p:txBody>
-          <a:bodyPr rtlCol="0" anchor="ctr" wrap="square" lIns="73152" rIns="73152" tIns="36576" bIns="36576"/>
+          <a:bodyPr wrap="square" lIns="73152" tIns="36576" rIns="73152" bIns="36576" rtlCol="0" anchor="ctr"/>
           <a:lstStyle/>
           <a:p>
             <a:pPr algn="ctr"/>
@@ -14036,7 +14280,7 @@
       <p:sp>
         <p:nvSpPr>
           <p:cNvPr id="8" name="Rounded Rectangle 7">
-            <a:hlinkClick action="ppaction://hlinksldjump" r:id="rId5"/>
+            <a:hlinkClick r:id="rId5" action="ppaction://hlinksldjump"/>
           </p:cNvPr>
           <p:cNvSpPr/>
           <p:nvPr/>
@@ -14071,7 +14315,7 @@
           </a:fontRef>
         </p:style>
         <p:txBody>
-          <a:bodyPr rtlCol="0" anchor="ctr" wrap="square" lIns="73152" rIns="73152" tIns="36576" bIns="36576"/>
+          <a:bodyPr wrap="square" lIns="73152" tIns="36576" rIns="73152" bIns="36576" rtlCol="0" anchor="ctr"/>
           <a:lstStyle/>
           <a:p>
             <a:pPr algn="ctr"/>
@@ -14090,7 +14334,7 @@
       <p:sp>
         <p:nvSpPr>
           <p:cNvPr id="9" name="Rounded Rectangle 8">
-            <a:hlinkClick action="ppaction://hlinksldjump" r:id="rId6"/>
+            <a:hlinkClick r:id="rId6" action="ppaction://hlinksldjump"/>
           </p:cNvPr>
           <p:cNvSpPr/>
           <p:nvPr/>
@@ -14125,7 +14369,7 @@
           </a:fontRef>
         </p:style>
         <p:txBody>
-          <a:bodyPr rtlCol="0" anchor="ctr" wrap="square" lIns="73152" rIns="73152" tIns="36576" bIns="36576"/>
+          <a:bodyPr wrap="square" lIns="73152" tIns="36576" rIns="73152" bIns="36576" rtlCol="0" anchor="ctr"/>
           <a:lstStyle/>
           <a:p>
             <a:pPr algn="ctr"/>
@@ -14144,7 +14388,7 @@
       <p:sp>
         <p:nvSpPr>
           <p:cNvPr id="10" name="Rounded Rectangle 9">
-            <a:hlinkClick action="ppaction://hlinksldjump" r:id="rId7"/>
+            <a:hlinkClick r:id="rId7" action="ppaction://hlinksldjump"/>
           </p:cNvPr>
           <p:cNvSpPr/>
           <p:nvPr/>
@@ -14179,7 +14423,7 @@
           </a:fontRef>
         </p:style>
         <p:txBody>
-          <a:bodyPr rtlCol="0" anchor="ctr" wrap="square" lIns="73152" rIns="73152" tIns="36576" bIns="36576"/>
+          <a:bodyPr wrap="square" lIns="73152" tIns="36576" rIns="73152" bIns="36576" rtlCol="0" anchor="ctr"/>
           <a:lstStyle/>
           <a:p>
             <a:pPr algn="ctr"/>
@@ -14198,7 +14442,7 @@
       <p:sp>
         <p:nvSpPr>
           <p:cNvPr id="11" name="Rounded Rectangle 10">
-            <a:hlinkClick action="ppaction://hlinksldjump" r:id="rId8"/>
+            <a:hlinkClick r:id="rId8" action="ppaction://hlinksldjump"/>
           </p:cNvPr>
           <p:cNvSpPr/>
           <p:nvPr/>
@@ -14233,7 +14477,7 @@
           </a:fontRef>
         </p:style>
         <p:txBody>
-          <a:bodyPr rtlCol="0" anchor="ctr" wrap="square" lIns="73152" rIns="73152" tIns="36576" bIns="36576"/>
+          <a:bodyPr wrap="square" lIns="73152" tIns="36576" rIns="73152" bIns="36576" rtlCol="0" anchor="ctr"/>
           <a:lstStyle/>
           <a:p>
             <a:pPr algn="ctr"/>
@@ -14252,7 +14496,7 @@
       <p:sp>
         <p:nvSpPr>
           <p:cNvPr id="12" name="Rounded Rectangle 11">
-            <a:hlinkClick action="ppaction://hlinksldjump" r:id="rId9"/>
+            <a:hlinkClick r:id="rId9" action="ppaction://hlinksldjump"/>
           </p:cNvPr>
           <p:cNvSpPr/>
           <p:nvPr/>
@@ -14287,7 +14531,7 @@
           </a:fontRef>
         </p:style>
         <p:txBody>
-          <a:bodyPr rtlCol="0" anchor="ctr" wrap="square" lIns="73152" rIns="73152" tIns="36576" bIns="36576"/>
+          <a:bodyPr wrap="square" lIns="73152" tIns="36576" rIns="73152" bIns="36576" rtlCol="0" anchor="ctr"/>
           <a:lstStyle/>
           <a:p>
             <a:pPr algn="ctr"/>
@@ -14306,7 +14550,7 @@
       <p:sp>
         <p:nvSpPr>
           <p:cNvPr id="13" name="Rounded Rectangle 12">
-            <a:hlinkClick action="ppaction://hlinksldjump" r:id="rId10"/>
+            <a:hlinkClick r:id="rId10" action="ppaction://hlinksldjump"/>
           </p:cNvPr>
           <p:cNvSpPr/>
           <p:nvPr/>
@@ -14341,7 +14585,7 @@
           </a:fontRef>
         </p:style>
         <p:txBody>
-          <a:bodyPr rtlCol="0" anchor="ctr" wrap="square" lIns="73152" rIns="73152" tIns="36576" bIns="36576"/>
+          <a:bodyPr wrap="square" lIns="73152" tIns="36576" rIns="73152" bIns="36576" rtlCol="0" anchor="ctr"/>
           <a:lstStyle/>
           <a:p>
             <a:pPr algn="ctr"/>
@@ -14399,6 +14643,7 @@
           <a:lstStyle/>
           <a:p>
             <a:pPr algn="ctr"/>
+            <a:endParaRPr/>
           </a:p>
         </p:txBody>
       </p:sp>
@@ -14492,6 +14737,7 @@
           <a:lstStyle/>
           <a:p>
             <a:pPr algn="ctr"/>
+            <a:endParaRPr/>
           </a:p>
         </p:txBody>
       </p:sp>
@@ -14567,7 +14813,7 @@
       <p:sp>
         <p:nvSpPr>
           <p:cNvPr id="20" name="Rounded Rectangle 19">
-            <a:hlinkClick action="ppaction://hlinksldjump" r:id="rId6"/>
+            <a:hlinkClick r:id="rId6" action="ppaction://hlinksldjump"/>
           </p:cNvPr>
           <p:cNvSpPr/>
           <p:nvPr/>
@@ -14604,7 +14850,7 @@
           </a:fontRef>
         </p:style>
         <p:txBody>
-          <a:bodyPr rtlCol="0" anchor="ctr" wrap="square" lIns="73152" rIns="73152" tIns="36576" bIns="36576"/>
+          <a:bodyPr wrap="square" lIns="73152" tIns="36576" rIns="73152" bIns="36576" rtlCol="0" anchor="ctr"/>
           <a:lstStyle/>
           <a:p>
             <a:pPr algn="ctr"/>
@@ -14623,7 +14869,7 @@
       <p:sp>
         <p:nvSpPr>
           <p:cNvPr id="21" name="Rounded Rectangle 20">
-            <a:hlinkClick action="ppaction://hlinksldjump" r:id="rId8"/>
+            <a:hlinkClick r:id="rId8" action="ppaction://hlinksldjump"/>
           </p:cNvPr>
           <p:cNvSpPr/>
           <p:nvPr/>
@@ -14658,7 +14904,7 @@
           </a:fontRef>
         </p:style>
         <p:txBody>
-          <a:bodyPr rtlCol="0" anchor="ctr" wrap="square" lIns="73152" rIns="73152" tIns="36576" bIns="36576"/>
+          <a:bodyPr wrap="square" lIns="73152" tIns="36576" rIns="73152" bIns="36576" rtlCol="0" anchor="ctr"/>
           <a:lstStyle/>
           <a:p>
             <a:pPr algn="ctr"/>
@@ -14716,6 +14962,7 @@
           <a:lstStyle/>
           <a:p>
             <a:pPr algn="ctr"/>
+            <a:endParaRPr/>
           </a:p>
         </p:txBody>
       </p:sp>
@@ -14805,6 +15052,7 @@
           <a:lstStyle/>
           <a:p>
             <a:pPr algn="ctr"/>
+            <a:endParaRPr/>
           </a:p>
         </p:txBody>
       </p:sp>
@@ -14896,6 +15144,7 @@
           <a:lstStyle/>
           <a:p>
             <a:pPr algn="ctr"/>
+            <a:endParaRPr/>
           </a:p>
         </p:txBody>
       </p:sp>
@@ -14987,6 +15236,7 @@
           <a:lstStyle/>
           <a:p>
             <a:pPr algn="ctr"/>
+            <a:endParaRPr/>
           </a:p>
         </p:txBody>
       </p:sp>
@@ -15078,6 +15328,7 @@
           <a:lstStyle/>
           <a:p>
             <a:pPr algn="ctr"/>
+            <a:endParaRPr/>
           </a:p>
         </p:txBody>
       </p:sp>
@@ -15169,6 +15420,7 @@
           <a:lstStyle/>
           <a:p>
             <a:pPr algn="ctr"/>
+            <a:endParaRPr/>
           </a:p>
         </p:txBody>
       </p:sp>
@@ -15260,6 +15512,7 @@
           <a:lstStyle/>
           <a:p>
             <a:pPr algn="ctr"/>
+            <a:endParaRPr/>
           </a:p>
         </p:txBody>
       </p:sp>
@@ -15351,6 +15604,7 @@
           <a:lstStyle/>
           <a:p>
             <a:pPr algn="ctr"/>
+            <a:endParaRPr/>
           </a:p>
         </p:txBody>
       </p:sp>
@@ -15442,6 +15696,7 @@
           <a:lstStyle/>
           <a:p>
             <a:pPr algn="ctr"/>
+            <a:endParaRPr/>
           </a:p>
         </p:txBody>
       </p:sp>
@@ -15535,6 +15790,7 @@
           <a:lstStyle/>
           <a:p>
             <a:pPr algn="ctr"/>
+            <a:endParaRPr/>
           </a:p>
         </p:txBody>
       </p:sp>
@@ -15590,7 +15846,7 @@
       <p:sp>
         <p:nvSpPr>
           <p:cNvPr id="42" name="Rounded Rectangle 41">
-            <a:hlinkClick action="ppaction://hlinksldjump" r:id="rId8"/>
+            <a:hlinkClick r:id="rId8" action="ppaction://hlinksldjump"/>
           </p:cNvPr>
           <p:cNvSpPr/>
           <p:nvPr/>
@@ -15625,7 +15881,7 @@
           </a:fontRef>
         </p:style>
         <p:txBody>
-          <a:bodyPr rtlCol="0" anchor="ctr" wrap="square" lIns="73152" rIns="73152" tIns="36576" bIns="36576"/>
+          <a:bodyPr wrap="square" lIns="73152" tIns="36576" rIns="73152" bIns="36576" rtlCol="0" anchor="ctr"/>
           <a:lstStyle/>
           <a:p>
             <a:pPr algn="ctr"/>
@@ -15650,7 +15906,7 @@
 </file>
 
 <file path=ppt/slides/slide6.xml><?xml version="1.0" encoding="utf-8"?>
-<p:sld xmlns:a="http://schemas.openxmlformats.org/drawingml/2006/main" xmlns:p="http://schemas.openxmlformats.org/presentationml/2006/main" xmlns:r="http://schemas.openxmlformats.org/officeDocument/2006/relationships">
+<p:sld xmlns:a="http://schemas.openxmlformats.org/drawingml/2006/main" xmlns:r="http://schemas.openxmlformats.org/officeDocument/2006/relationships" xmlns:p="http://schemas.openxmlformats.org/presentationml/2006/main">
   <p:cSld>
     <p:spTree>
       <p:nvGrpSpPr>
@@ -15658,7 +15914,14 @@
         <p:cNvGrpSpPr/>
         <p:nvPr/>
       </p:nvGrpSpPr>
-      <p:grpSpPr/>
+      <p:grpSpPr>
+        <a:xfrm>
+          <a:off x="0" y="0"/>
+          <a:ext cx="0" cy="0"/>
+          <a:chOff x="0" y="0"/>
+          <a:chExt cx="0" cy="0"/>
+        </a:xfrm>
+      </p:grpSpPr>
       <p:sp>
         <p:nvSpPr>
           <p:cNvPr id="2" name="Rectangle 1"/>
@@ -15699,6 +15962,7 @@
           <a:lstStyle/>
           <a:p>
             <a:pPr algn="ctr"/>
+            <a:endParaRPr/>
           </a:p>
         </p:txBody>
       </p:sp>
@@ -15768,6 +16032,7 @@
           <a:lstStyle/>
           <a:p>
             <a:pPr algn="ctr"/>
+            <a:endParaRPr/>
           </a:p>
         </p:txBody>
       </p:sp>
@@ -15818,7 +16083,7 @@
           <a:lstStyle/>
           <a:p>
             <a:r>
-              <a:rPr b="1" sz="1300">
+              <a:rPr sz="1300" b="1">
                 <a:solidFill>
                   <a:srgbClr val="4F46E5"/>
                 </a:solidFill>
@@ -15827,7 +16092,7 @@
               <a:t>CompliScan </a:t>
             </a:r>
             <a:r>
-              <a:rPr b="1" sz="1300">
+              <a:rPr sz="1300" b="1">
                 <a:solidFill>
                   <a:srgbClr val="10B981"/>
                 </a:solidFill>
@@ -15852,7 +16117,7 @@
       <p:sp>
         <p:nvSpPr>
           <p:cNvPr id="7" name="Rounded Rectangle 6">
-            <a:hlinkClick action="ppaction://hlinksldjump" r:id="rId4"/>
+            <a:hlinkClick r:id="rId4" action="ppaction://hlinksldjump"/>
           </p:cNvPr>
           <p:cNvSpPr/>
           <p:nvPr/>
@@ -15887,7 +16152,7 @@
           </a:fontRef>
         </p:style>
         <p:txBody>
-          <a:bodyPr rtlCol="0" anchor="ctr" wrap="square" lIns="73152" rIns="73152" tIns="36576" bIns="36576"/>
+          <a:bodyPr wrap="square" lIns="73152" tIns="36576" rIns="73152" bIns="36576" rtlCol="0" anchor="ctr"/>
           <a:lstStyle/>
           <a:p>
             <a:pPr algn="ctr"/>
@@ -15906,7 +16171,7 @@
       <p:sp>
         <p:nvSpPr>
           <p:cNvPr id="8" name="Rounded Rectangle 7">
-            <a:hlinkClick action="ppaction://hlinksldjump" r:id="rId5"/>
+            <a:hlinkClick r:id="rId5" action="ppaction://hlinksldjump"/>
           </p:cNvPr>
           <p:cNvSpPr/>
           <p:nvPr/>
@@ -15941,7 +16206,7 @@
           </a:fontRef>
         </p:style>
         <p:txBody>
-          <a:bodyPr rtlCol="0" anchor="ctr" wrap="square" lIns="73152" rIns="73152" tIns="36576" bIns="36576"/>
+          <a:bodyPr wrap="square" lIns="73152" tIns="36576" rIns="73152" bIns="36576" rtlCol="0" anchor="ctr"/>
           <a:lstStyle/>
           <a:p>
             <a:pPr algn="ctr"/>
@@ -15960,7 +16225,7 @@
       <p:sp>
         <p:nvSpPr>
           <p:cNvPr id="9" name="Rounded Rectangle 8">
-            <a:hlinkClick action="ppaction://hlinksldjump" r:id="rId6"/>
+            <a:hlinkClick r:id="rId6" action="ppaction://hlinksldjump"/>
           </p:cNvPr>
           <p:cNvSpPr/>
           <p:nvPr/>
@@ -15995,7 +16260,7 @@
           </a:fontRef>
         </p:style>
         <p:txBody>
-          <a:bodyPr rtlCol="0" anchor="ctr" wrap="square" lIns="73152" rIns="73152" tIns="36576" bIns="36576"/>
+          <a:bodyPr wrap="square" lIns="73152" tIns="36576" rIns="73152" bIns="36576" rtlCol="0" anchor="ctr"/>
           <a:lstStyle/>
           <a:p>
             <a:pPr algn="ctr"/>
@@ -16014,7 +16279,7 @@
       <p:sp>
         <p:nvSpPr>
           <p:cNvPr id="10" name="Rounded Rectangle 9">
-            <a:hlinkClick action="ppaction://hlinksldjump" r:id="rId7"/>
+            <a:hlinkClick r:id="rId7" action="ppaction://hlinksldjump"/>
           </p:cNvPr>
           <p:cNvSpPr/>
           <p:nvPr/>
@@ -16049,7 +16314,7 @@
           </a:fontRef>
         </p:style>
         <p:txBody>
-          <a:bodyPr rtlCol="0" anchor="ctr" wrap="square" lIns="73152" rIns="73152" tIns="36576" bIns="36576"/>
+          <a:bodyPr wrap="square" lIns="73152" tIns="36576" rIns="73152" bIns="36576" rtlCol="0" anchor="ctr"/>
           <a:lstStyle/>
           <a:p>
             <a:pPr algn="ctr"/>
@@ -16068,7 +16333,7 @@
       <p:sp>
         <p:nvSpPr>
           <p:cNvPr id="11" name="Rounded Rectangle 10">
-            <a:hlinkClick action="ppaction://hlinksldjump" r:id="rId8"/>
+            <a:hlinkClick r:id="rId8" action="ppaction://hlinksldjump"/>
           </p:cNvPr>
           <p:cNvSpPr/>
           <p:nvPr/>
@@ -16103,7 +16368,7 @@
           </a:fontRef>
         </p:style>
         <p:txBody>
-          <a:bodyPr rtlCol="0" anchor="ctr" wrap="square" lIns="73152" rIns="73152" tIns="36576" bIns="36576"/>
+          <a:bodyPr wrap="square" lIns="73152" tIns="36576" rIns="73152" bIns="36576" rtlCol="0" anchor="ctr"/>
           <a:lstStyle/>
           <a:p>
             <a:pPr algn="ctr"/>
@@ -16122,7 +16387,7 @@
       <p:sp>
         <p:nvSpPr>
           <p:cNvPr id="12" name="Rounded Rectangle 11">
-            <a:hlinkClick action="ppaction://hlinksldjump" r:id="rId9"/>
+            <a:hlinkClick r:id="rId9" action="ppaction://hlinksldjump"/>
           </p:cNvPr>
           <p:cNvSpPr/>
           <p:nvPr/>
@@ -16157,7 +16422,7 @@
           </a:fontRef>
         </p:style>
         <p:txBody>
-          <a:bodyPr rtlCol="0" anchor="ctr" wrap="square" lIns="73152" rIns="73152" tIns="36576" bIns="36576"/>
+          <a:bodyPr wrap="square" lIns="73152" tIns="36576" rIns="73152" bIns="36576" rtlCol="0" anchor="ctr"/>
           <a:lstStyle/>
           <a:p>
             <a:pPr algn="ctr"/>
@@ -16176,7 +16441,7 @@
       <p:sp>
         <p:nvSpPr>
           <p:cNvPr id="13" name="Rounded Rectangle 12">
-            <a:hlinkClick action="ppaction://hlinksldjump" r:id="rId10"/>
+            <a:hlinkClick r:id="rId10" action="ppaction://hlinksldjump"/>
           </p:cNvPr>
           <p:cNvSpPr/>
           <p:nvPr/>
@@ -16211,7 +16476,7 @@
           </a:fontRef>
         </p:style>
         <p:txBody>
-          <a:bodyPr rtlCol="0" anchor="ctr" wrap="square" lIns="73152" rIns="73152" tIns="36576" bIns="36576"/>
+          <a:bodyPr wrap="square" lIns="73152" tIns="36576" rIns="73152" bIns="36576" rtlCol="0" anchor="ctr"/>
           <a:lstStyle/>
           <a:p>
             <a:pPr algn="ctr"/>
@@ -16269,6 +16534,7 @@
           <a:lstStyle/>
           <a:p>
             <a:pPr algn="ctr"/>
+            <a:endParaRPr/>
           </a:p>
         </p:txBody>
       </p:sp>
@@ -16362,6 +16628,7 @@
           <a:lstStyle/>
           <a:p>
             <a:pPr algn="ctr"/>
+            <a:endParaRPr/>
           </a:p>
         </p:txBody>
       </p:sp>
@@ -16437,7 +16704,7 @@
       <p:sp>
         <p:nvSpPr>
           <p:cNvPr id="20" name="Rounded Rectangle 19">
-            <a:hlinkClick action="ppaction://hlinksldjump" r:id="rId7"/>
+            <a:hlinkClick r:id="rId7" action="ppaction://hlinksldjump"/>
           </p:cNvPr>
           <p:cNvSpPr/>
           <p:nvPr/>
@@ -16474,7 +16741,7 @@
           </a:fontRef>
         </p:style>
         <p:txBody>
-          <a:bodyPr rtlCol="0" anchor="ctr" wrap="square" lIns="73152" rIns="73152" tIns="36576" bIns="36576"/>
+          <a:bodyPr wrap="square" lIns="73152" tIns="36576" rIns="73152" bIns="36576" rtlCol="0" anchor="ctr"/>
           <a:lstStyle/>
           <a:p>
             <a:pPr algn="ctr"/>
@@ -16493,7 +16760,7 @@
       <p:sp>
         <p:nvSpPr>
           <p:cNvPr id="21" name="Rounded Rectangle 20">
-            <a:hlinkClick action="ppaction://hlinksldjump" r:id="rId13"/>
+            <a:hlinkClick r:id="rId13" action="ppaction://hlinksldjump"/>
           </p:cNvPr>
           <p:cNvSpPr/>
           <p:nvPr/>
@@ -16528,7 +16795,7 @@
           </a:fontRef>
         </p:style>
         <p:txBody>
-          <a:bodyPr rtlCol="0" anchor="ctr" wrap="square" lIns="73152" rIns="73152" tIns="36576" bIns="36576"/>
+          <a:bodyPr wrap="square" lIns="73152" tIns="36576" rIns="73152" bIns="36576" rtlCol="0" anchor="ctr"/>
           <a:lstStyle/>
           <a:p>
             <a:pPr algn="ctr"/>
@@ -16586,6 +16853,7 @@
           <a:lstStyle/>
           <a:p>
             <a:pPr algn="ctr"/>
+            <a:endParaRPr/>
           </a:p>
         </p:txBody>
       </p:sp>
@@ -16631,6 +16899,7 @@
           <a:lstStyle/>
           <a:p>
             <a:pPr algn="ctr"/>
+            <a:endParaRPr/>
           </a:p>
         </p:txBody>
       </p:sp>
@@ -16724,6 +16993,7 @@
           <a:lstStyle/>
           <a:p>
             <a:pPr algn="ctr"/>
+            <a:endParaRPr/>
           </a:p>
         </p:txBody>
       </p:sp>
@@ -16815,6 +17085,7 @@
           <a:lstStyle/>
           <a:p>
             <a:pPr algn="ctr"/>
+            <a:endParaRPr/>
           </a:p>
         </p:txBody>
       </p:sp>
@@ -16906,6 +17177,7 @@
           <a:lstStyle/>
           <a:p>
             <a:pPr algn="ctr"/>
+            <a:endParaRPr/>
           </a:p>
         </p:txBody>
       </p:sp>
@@ -16997,6 +17269,7 @@
           <a:lstStyle/>
           <a:p>
             <a:pPr algn="ctr"/>
+            <a:endParaRPr/>
           </a:p>
         </p:txBody>
       </p:sp>
@@ -17088,6 +17361,7 @@
           <a:lstStyle/>
           <a:p>
             <a:pPr algn="ctr"/>
+            <a:endParaRPr/>
           </a:p>
         </p:txBody>
       </p:sp>
@@ -17177,6 +17451,7 @@
           <a:lstStyle/>
           <a:p>
             <a:pPr algn="ctr"/>
+            <a:endParaRPr/>
           </a:p>
         </p:txBody>
       </p:sp>
@@ -17222,6 +17497,7 @@
           <a:lstStyle/>
           <a:p>
             <a:pPr algn="ctr"/>
+            <a:endParaRPr/>
           </a:p>
         </p:txBody>
       </p:sp>
@@ -17301,6 +17577,7 @@
           <a:lstStyle/>
           <a:p>
             <a:pPr algn="ctr"/>
+            <a:endParaRPr/>
           </a:p>
         </p:txBody>
       </p:sp>
@@ -17389,6 +17666,7 @@
           <a:lstStyle/>
           <a:p>
             <a:pPr algn="ctr"/>
+            <a:endParaRPr/>
           </a:p>
         </p:txBody>
       </p:sp>
@@ -17477,6 +17755,7 @@
           <a:lstStyle/>
           <a:p>
             <a:pPr algn="ctr"/>
+            <a:endParaRPr/>
           </a:p>
         </p:txBody>
       </p:sp>
@@ -17565,6 +17844,7 @@
           <a:lstStyle/>
           <a:p>
             <a:pPr algn="ctr"/>
+            <a:endParaRPr/>
           </a:p>
         </p:txBody>
       </p:sp>
@@ -17653,6 +17933,7 @@
           <a:lstStyle/>
           <a:p>
             <a:pPr algn="ctr"/>
+            <a:endParaRPr/>
           </a:p>
         </p:txBody>
       </p:sp>
@@ -17679,7 +17960,7 @@
           <a:lstStyle/>
           <a:p>
             <a:r>
-              <a:rPr sz="900">
+              <a:rPr sz="900" dirty="0">
                 <a:solidFill>
                   <a:srgbClr val="0F172A"/>
                 </a:solidFill>
@@ -17688,7 +17969,7 @@
               <a:t>LM-005       Month &amp; Year of Manufacture            Missing specific calendar date </a:t>
             </a:r>
             <a:r>
-              <a:rPr sz="950" b="1">
+              <a:rPr sz="950" b="1" dirty="0">
                 <a:solidFill>
                   <a:srgbClr val="EF4444"/>
                 </a:solidFill>
@@ -17741,6 +18022,7 @@
           <a:lstStyle/>
           <a:p>
             <a:pPr algn="ctr"/>
+            <a:endParaRPr/>
           </a:p>
         </p:txBody>
       </p:sp>
@@ -17829,6 +18111,7 @@
           <a:lstStyle/>
           <a:p>
             <a:pPr algn="ctr"/>
+            <a:endParaRPr/>
           </a:p>
         </p:txBody>
       </p:sp>
@@ -17878,7 +18161,7 @@
       <p:sp>
         <p:nvSpPr>
           <p:cNvPr id="52" name="Rounded Rectangle 51">
-            <a:hlinkClick action="ppaction://hlinksldjump" r:id="rId13"/>
+            <a:hlinkClick r:id="rId13" action="ppaction://hlinksldjump"/>
           </p:cNvPr>
           <p:cNvSpPr/>
           <p:nvPr/>
@@ -17913,7 +18196,7 @@
           </a:fontRef>
         </p:style>
         <p:txBody>
-          <a:bodyPr rtlCol="0" anchor="ctr" wrap="square" lIns="73152" rIns="73152" tIns="36576" bIns="36576"/>
+          <a:bodyPr wrap="square" lIns="73152" tIns="36576" rIns="73152" bIns="36576" rtlCol="0" anchor="ctr"/>
           <a:lstStyle/>
           <a:p>
             <a:pPr algn="ctr"/>
@@ -17938,7 +18221,7 @@
 </file>
 
 <file path=ppt/slides/slide7.xml><?xml version="1.0" encoding="utf-8"?>
-<p:sld xmlns:a="http://schemas.openxmlformats.org/drawingml/2006/main" xmlns:p="http://schemas.openxmlformats.org/presentationml/2006/main" xmlns:r="http://schemas.openxmlformats.org/officeDocument/2006/relationships">
+<p:sld xmlns:a="http://schemas.openxmlformats.org/drawingml/2006/main" xmlns:r="http://schemas.openxmlformats.org/officeDocument/2006/relationships" xmlns:p="http://schemas.openxmlformats.org/presentationml/2006/main">
   <p:cSld>
     <p:spTree>
       <p:nvGrpSpPr>
@@ -17946,7 +18229,14 @@
         <p:cNvGrpSpPr/>
         <p:nvPr/>
       </p:nvGrpSpPr>
-      <p:grpSpPr/>
+      <p:grpSpPr>
+        <a:xfrm>
+          <a:off x="0" y="0"/>
+          <a:ext cx="0" cy="0"/>
+          <a:chOff x="0" y="0"/>
+          <a:chExt cx="0" cy="0"/>
+        </a:xfrm>
+      </p:grpSpPr>
       <p:sp>
         <p:nvSpPr>
           <p:cNvPr id="2" name="Rectangle 1"/>
@@ -17987,6 +18277,7 @@
           <a:lstStyle/>
           <a:p>
             <a:pPr algn="ctr"/>
+            <a:endParaRPr/>
           </a:p>
         </p:txBody>
       </p:sp>
@@ -18056,6 +18347,7 @@
           <a:lstStyle/>
           <a:p>
             <a:pPr algn="ctr"/>
+            <a:endParaRPr/>
           </a:p>
         </p:txBody>
       </p:sp>
@@ -18106,7 +18398,7 @@
           <a:lstStyle/>
           <a:p>
             <a:r>
-              <a:rPr b="1" sz="1300">
+              <a:rPr sz="1300" b="1">
                 <a:solidFill>
                   <a:srgbClr val="4F46E5"/>
                 </a:solidFill>
@@ -18115,7 +18407,7 @@
               <a:t>CompliScan </a:t>
             </a:r>
             <a:r>
-              <a:rPr b="1" sz="1300">
+              <a:rPr sz="1300" b="1">
                 <a:solidFill>
                   <a:srgbClr val="10B981"/>
                 </a:solidFill>
@@ -18140,7 +18432,7 @@
       <p:sp>
         <p:nvSpPr>
           <p:cNvPr id="7" name="Rounded Rectangle 6">
-            <a:hlinkClick action="ppaction://hlinksldjump" r:id="rId4"/>
+            <a:hlinkClick r:id="rId4" action="ppaction://hlinksldjump"/>
           </p:cNvPr>
           <p:cNvSpPr/>
           <p:nvPr/>
@@ -18175,7 +18467,7 @@
           </a:fontRef>
         </p:style>
         <p:txBody>
-          <a:bodyPr rtlCol="0" anchor="ctr" wrap="square" lIns="73152" rIns="73152" tIns="36576" bIns="36576"/>
+          <a:bodyPr wrap="square" lIns="73152" tIns="36576" rIns="73152" bIns="36576" rtlCol="0" anchor="ctr"/>
           <a:lstStyle/>
           <a:p>
             <a:pPr algn="ctr"/>
@@ -18194,7 +18486,7 @@
       <p:sp>
         <p:nvSpPr>
           <p:cNvPr id="8" name="Rounded Rectangle 7">
-            <a:hlinkClick action="ppaction://hlinksldjump" r:id="rId5"/>
+            <a:hlinkClick r:id="rId5" action="ppaction://hlinksldjump"/>
           </p:cNvPr>
           <p:cNvSpPr/>
           <p:nvPr/>
@@ -18229,7 +18521,7 @@
           </a:fontRef>
         </p:style>
         <p:txBody>
-          <a:bodyPr rtlCol="0" anchor="ctr" wrap="square" lIns="73152" rIns="73152" tIns="36576" bIns="36576"/>
+          <a:bodyPr wrap="square" lIns="73152" tIns="36576" rIns="73152" bIns="36576" rtlCol="0" anchor="ctr"/>
           <a:lstStyle/>
           <a:p>
             <a:pPr algn="ctr"/>
@@ -18248,7 +18540,7 @@
       <p:sp>
         <p:nvSpPr>
           <p:cNvPr id="9" name="Rounded Rectangle 8">
-            <a:hlinkClick action="ppaction://hlinksldjump" r:id="rId6"/>
+            <a:hlinkClick r:id="rId6" action="ppaction://hlinksldjump"/>
           </p:cNvPr>
           <p:cNvSpPr/>
           <p:nvPr/>
@@ -18283,7 +18575,7 @@
           </a:fontRef>
         </p:style>
         <p:txBody>
-          <a:bodyPr rtlCol="0" anchor="ctr" wrap="square" lIns="73152" rIns="73152" tIns="36576" bIns="36576"/>
+          <a:bodyPr wrap="square" lIns="73152" tIns="36576" rIns="73152" bIns="36576" rtlCol="0" anchor="ctr"/>
           <a:lstStyle/>
           <a:p>
             <a:pPr algn="ctr"/>
@@ -18302,7 +18594,7 @@
       <p:sp>
         <p:nvSpPr>
           <p:cNvPr id="10" name="Rounded Rectangle 9">
-            <a:hlinkClick action="ppaction://hlinksldjump" r:id="rId7"/>
+            <a:hlinkClick r:id="rId7" action="ppaction://hlinksldjump"/>
           </p:cNvPr>
           <p:cNvSpPr/>
           <p:nvPr/>
@@ -18337,7 +18629,7 @@
           </a:fontRef>
         </p:style>
         <p:txBody>
-          <a:bodyPr rtlCol="0" anchor="ctr" wrap="square" lIns="73152" rIns="73152" tIns="36576" bIns="36576"/>
+          <a:bodyPr wrap="square" lIns="73152" tIns="36576" rIns="73152" bIns="36576" rtlCol="0" anchor="ctr"/>
           <a:lstStyle/>
           <a:p>
             <a:pPr algn="ctr"/>
@@ -18356,7 +18648,7 @@
       <p:sp>
         <p:nvSpPr>
           <p:cNvPr id="11" name="Rounded Rectangle 10">
-            <a:hlinkClick action="ppaction://hlinksldjump" r:id="rId8"/>
+            <a:hlinkClick r:id="rId8" action="ppaction://hlinksldjump"/>
           </p:cNvPr>
           <p:cNvSpPr/>
           <p:nvPr/>
@@ -18391,7 +18683,7 @@
           </a:fontRef>
         </p:style>
         <p:txBody>
-          <a:bodyPr rtlCol="0" anchor="ctr" wrap="square" lIns="73152" rIns="73152" tIns="36576" bIns="36576"/>
+          <a:bodyPr wrap="square" lIns="73152" tIns="36576" rIns="73152" bIns="36576" rtlCol="0" anchor="ctr"/>
           <a:lstStyle/>
           <a:p>
             <a:pPr algn="ctr"/>
@@ -18410,7 +18702,7 @@
       <p:sp>
         <p:nvSpPr>
           <p:cNvPr id="12" name="Rounded Rectangle 11">
-            <a:hlinkClick action="ppaction://hlinksldjump" r:id="rId9"/>
+            <a:hlinkClick r:id="rId9" action="ppaction://hlinksldjump"/>
           </p:cNvPr>
           <p:cNvSpPr/>
           <p:nvPr/>
@@ -18445,7 +18737,7 @@
           </a:fontRef>
         </p:style>
         <p:txBody>
-          <a:bodyPr rtlCol="0" anchor="ctr" wrap="square" lIns="73152" rIns="73152" tIns="36576" bIns="36576"/>
+          <a:bodyPr wrap="square" lIns="73152" tIns="36576" rIns="73152" bIns="36576" rtlCol="0" anchor="ctr"/>
           <a:lstStyle/>
           <a:p>
             <a:pPr algn="ctr"/>
@@ -18464,7 +18756,7 @@
       <p:sp>
         <p:nvSpPr>
           <p:cNvPr id="13" name="Rounded Rectangle 12">
-            <a:hlinkClick action="ppaction://hlinksldjump" r:id="rId10"/>
+            <a:hlinkClick r:id="rId10" action="ppaction://hlinksldjump"/>
           </p:cNvPr>
           <p:cNvSpPr/>
           <p:nvPr/>
@@ -18499,7 +18791,7 @@
           </a:fontRef>
         </p:style>
         <p:txBody>
-          <a:bodyPr rtlCol="0" anchor="ctr" wrap="square" lIns="73152" rIns="73152" tIns="36576" bIns="36576"/>
+          <a:bodyPr wrap="square" lIns="73152" tIns="36576" rIns="73152" bIns="36576" rtlCol="0" anchor="ctr"/>
           <a:lstStyle/>
           <a:p>
             <a:pPr algn="ctr"/>
@@ -18557,6 +18849,7 @@
           <a:lstStyle/>
           <a:p>
             <a:pPr algn="ctr"/>
+            <a:endParaRPr/>
           </a:p>
         </p:txBody>
       </p:sp>
@@ -18650,6 +18943,7 @@
           <a:lstStyle/>
           <a:p>
             <a:pPr algn="ctr"/>
+            <a:endParaRPr/>
           </a:p>
         </p:txBody>
       </p:sp>
@@ -18725,7 +19019,7 @@
       <p:sp>
         <p:nvSpPr>
           <p:cNvPr id="20" name="Rounded Rectangle 19">
-            <a:hlinkClick action="ppaction://hlinksldjump" r:id="rId8"/>
+            <a:hlinkClick r:id="rId8" action="ppaction://hlinksldjump"/>
           </p:cNvPr>
           <p:cNvSpPr/>
           <p:nvPr/>
@@ -18762,7 +19056,7 @@
           </a:fontRef>
         </p:style>
         <p:txBody>
-          <a:bodyPr rtlCol="0" anchor="ctr" wrap="square" lIns="73152" rIns="73152" tIns="36576" bIns="36576"/>
+          <a:bodyPr wrap="square" lIns="73152" tIns="36576" rIns="73152" bIns="36576" rtlCol="0" anchor="ctr"/>
           <a:lstStyle/>
           <a:p>
             <a:pPr algn="ctr"/>
@@ -18781,7 +19075,7 @@
       <p:sp>
         <p:nvSpPr>
           <p:cNvPr id="21" name="Rounded Rectangle 20">
-            <a:hlinkClick action="ppaction://hlinksldjump" r:id="rId9"/>
+            <a:hlinkClick r:id="rId9" action="ppaction://hlinksldjump"/>
           </p:cNvPr>
           <p:cNvSpPr/>
           <p:nvPr/>
@@ -18816,7 +19110,7 @@
           </a:fontRef>
         </p:style>
         <p:txBody>
-          <a:bodyPr rtlCol="0" anchor="ctr" wrap="square" lIns="73152" rIns="73152" tIns="36576" bIns="36576"/>
+          <a:bodyPr wrap="square" lIns="73152" tIns="36576" rIns="73152" bIns="36576" rtlCol="0" anchor="ctr"/>
           <a:lstStyle/>
           <a:p>
             <a:pPr algn="ctr"/>
@@ -18874,6 +19168,7 @@
           <a:lstStyle/>
           <a:p>
             <a:pPr algn="ctr"/>
+            <a:endParaRPr/>
           </a:p>
         </p:txBody>
       </p:sp>
@@ -18919,6 +19214,7 @@
           <a:lstStyle/>
           <a:p>
             <a:pPr algn="ctr"/>
+            <a:endParaRPr/>
           </a:p>
         </p:txBody>
       </p:sp>
@@ -19111,6 +19407,7 @@
           <a:lstStyle/>
           <a:p>
             <a:pPr algn="ctr"/>
+            <a:endParaRPr/>
           </a:p>
         </p:txBody>
       </p:sp>
@@ -19190,6 +19487,7 @@
           <a:lstStyle/>
           <a:p>
             <a:pPr algn="ctr"/>
+            <a:endParaRPr/>
           </a:p>
         </p:txBody>
       </p:sp>
@@ -19281,6 +19579,7 @@
           <a:lstStyle/>
           <a:p>
             <a:pPr algn="ctr"/>
+            <a:endParaRPr/>
           </a:p>
         </p:txBody>
       </p:sp>
@@ -19372,6 +19671,7 @@
           <a:lstStyle/>
           <a:p>
             <a:pPr algn="ctr"/>
+            <a:endParaRPr/>
           </a:p>
         </p:txBody>
       </p:sp>
@@ -19424,7 +19724,7 @@
       <p:sp>
         <p:nvSpPr>
           <p:cNvPr id="35" name="Rounded Rectangle 34">
-            <a:hlinkClick action="ppaction://hlinksldjump" r:id="rId9"/>
+            <a:hlinkClick r:id="rId9" action="ppaction://hlinksldjump"/>
           </p:cNvPr>
           <p:cNvSpPr/>
           <p:nvPr/>
@@ -19459,7 +19759,7 @@
           </a:fontRef>
         </p:style>
         <p:txBody>
-          <a:bodyPr rtlCol="0" anchor="ctr" wrap="square" lIns="73152" rIns="73152" tIns="36576" bIns="36576"/>
+          <a:bodyPr wrap="square" lIns="73152" tIns="36576" rIns="73152" bIns="36576" rtlCol="0" anchor="ctr"/>
           <a:lstStyle/>
           <a:p>
             <a:pPr algn="ctr"/>
@@ -19484,7 +19784,7 @@
 </file>
 
 <file path=ppt/slides/slide8.xml><?xml version="1.0" encoding="utf-8"?>
-<p:sld xmlns:a="http://schemas.openxmlformats.org/drawingml/2006/main" xmlns:p="http://schemas.openxmlformats.org/presentationml/2006/main" xmlns:r="http://schemas.openxmlformats.org/officeDocument/2006/relationships">
+<p:sld xmlns:a="http://schemas.openxmlformats.org/drawingml/2006/main" xmlns:r="http://schemas.openxmlformats.org/officeDocument/2006/relationships" xmlns:p="http://schemas.openxmlformats.org/presentationml/2006/main">
   <p:cSld>
     <p:spTree>
       <p:nvGrpSpPr>
@@ -19492,7 +19792,14 @@
         <p:cNvGrpSpPr/>
         <p:nvPr/>
       </p:nvGrpSpPr>
-      <p:grpSpPr/>
+      <p:grpSpPr>
+        <a:xfrm>
+          <a:off x="0" y="0"/>
+          <a:ext cx="0" cy="0"/>
+          <a:chOff x="0" y="0"/>
+          <a:chExt cx="0" cy="0"/>
+        </a:xfrm>
+      </p:grpSpPr>
       <p:sp>
         <p:nvSpPr>
           <p:cNvPr id="2" name="Rectangle 1"/>
@@ -19533,6 +19840,7 @@
           <a:lstStyle/>
           <a:p>
             <a:pPr algn="ctr"/>
+            <a:endParaRPr/>
           </a:p>
         </p:txBody>
       </p:sp>
@@ -19602,6 +19910,7 @@
           <a:lstStyle/>
           <a:p>
             <a:pPr algn="ctr"/>
+            <a:endParaRPr/>
           </a:p>
         </p:txBody>
       </p:sp>
@@ -19652,7 +19961,7 @@
           <a:lstStyle/>
           <a:p>
             <a:r>
-              <a:rPr b="1" sz="1300">
+              <a:rPr sz="1300" b="1">
                 <a:solidFill>
                   <a:srgbClr val="4F46E5"/>
                 </a:solidFill>
@@ -19661,7 +19970,7 @@
               <a:t>CompliScan </a:t>
             </a:r>
             <a:r>
-              <a:rPr b="1" sz="1300">
+              <a:rPr sz="1300" b="1">
                 <a:solidFill>
                   <a:srgbClr val="10B981"/>
                 </a:solidFill>
@@ -19686,7 +19995,7 @@
       <p:sp>
         <p:nvSpPr>
           <p:cNvPr id="7" name="Rounded Rectangle 6">
-            <a:hlinkClick action="ppaction://hlinksldjump" r:id="rId4"/>
+            <a:hlinkClick r:id="rId4" action="ppaction://hlinksldjump"/>
           </p:cNvPr>
           <p:cNvSpPr/>
           <p:nvPr/>
@@ -19721,7 +20030,7 @@
           </a:fontRef>
         </p:style>
         <p:txBody>
-          <a:bodyPr rtlCol="0" anchor="ctr" wrap="square" lIns="73152" rIns="73152" tIns="36576" bIns="36576"/>
+          <a:bodyPr wrap="square" lIns="73152" tIns="36576" rIns="73152" bIns="36576" rtlCol="0" anchor="ctr"/>
           <a:lstStyle/>
           <a:p>
             <a:pPr algn="ctr"/>
@@ -19740,7 +20049,7 @@
       <p:sp>
         <p:nvSpPr>
           <p:cNvPr id="8" name="Rounded Rectangle 7">
-            <a:hlinkClick action="ppaction://hlinksldjump" r:id="rId5"/>
+            <a:hlinkClick r:id="rId5" action="ppaction://hlinksldjump"/>
           </p:cNvPr>
           <p:cNvSpPr/>
           <p:nvPr/>
@@ -19775,7 +20084,7 @@
           </a:fontRef>
         </p:style>
         <p:txBody>
-          <a:bodyPr rtlCol="0" anchor="ctr" wrap="square" lIns="73152" rIns="73152" tIns="36576" bIns="36576"/>
+          <a:bodyPr wrap="square" lIns="73152" tIns="36576" rIns="73152" bIns="36576" rtlCol="0" anchor="ctr"/>
           <a:lstStyle/>
           <a:p>
             <a:pPr algn="ctr"/>
@@ -19794,7 +20103,7 @@
       <p:sp>
         <p:nvSpPr>
           <p:cNvPr id="9" name="Rounded Rectangle 8">
-            <a:hlinkClick action="ppaction://hlinksldjump" r:id="rId6"/>
+            <a:hlinkClick r:id="rId6" action="ppaction://hlinksldjump"/>
           </p:cNvPr>
           <p:cNvSpPr/>
           <p:nvPr/>
@@ -19829,7 +20138,7 @@
           </a:fontRef>
         </p:style>
         <p:txBody>
-          <a:bodyPr rtlCol="0" anchor="ctr" wrap="square" lIns="73152" rIns="73152" tIns="36576" bIns="36576"/>
+          <a:bodyPr wrap="square" lIns="73152" tIns="36576" rIns="73152" bIns="36576" rtlCol="0" anchor="ctr"/>
           <a:lstStyle/>
           <a:p>
             <a:pPr algn="ctr"/>
@@ -19848,7 +20157,7 @@
       <p:sp>
         <p:nvSpPr>
           <p:cNvPr id="10" name="Rounded Rectangle 9">
-            <a:hlinkClick action="ppaction://hlinksldjump" r:id="rId7"/>
+            <a:hlinkClick r:id="rId7" action="ppaction://hlinksldjump"/>
           </p:cNvPr>
           <p:cNvSpPr/>
           <p:nvPr/>
@@ -19883,7 +20192,7 @@
           </a:fontRef>
         </p:style>
         <p:txBody>
-          <a:bodyPr rtlCol="0" anchor="ctr" wrap="square" lIns="73152" rIns="73152" tIns="36576" bIns="36576"/>
+          <a:bodyPr wrap="square" lIns="73152" tIns="36576" rIns="73152" bIns="36576" rtlCol="0" anchor="ctr"/>
           <a:lstStyle/>
           <a:p>
             <a:pPr algn="ctr"/>
@@ -19902,7 +20211,7 @@
       <p:sp>
         <p:nvSpPr>
           <p:cNvPr id="11" name="Rounded Rectangle 10">
-            <a:hlinkClick action="ppaction://hlinksldjump" r:id="rId8"/>
+            <a:hlinkClick r:id="rId8" action="ppaction://hlinksldjump"/>
           </p:cNvPr>
           <p:cNvSpPr/>
           <p:nvPr/>
@@ -19937,7 +20246,7 @@
           </a:fontRef>
         </p:style>
         <p:txBody>
-          <a:bodyPr rtlCol="0" anchor="ctr" wrap="square" lIns="73152" rIns="73152" tIns="36576" bIns="36576"/>
+          <a:bodyPr wrap="square" lIns="73152" tIns="36576" rIns="73152" bIns="36576" rtlCol="0" anchor="ctr"/>
           <a:lstStyle/>
           <a:p>
             <a:pPr algn="ctr"/>
@@ -19956,7 +20265,7 @@
       <p:sp>
         <p:nvSpPr>
           <p:cNvPr id="12" name="Rounded Rectangle 11">
-            <a:hlinkClick action="ppaction://hlinksldjump" r:id="rId9"/>
+            <a:hlinkClick r:id="rId9" action="ppaction://hlinksldjump"/>
           </p:cNvPr>
           <p:cNvSpPr/>
           <p:nvPr/>
@@ -19991,7 +20300,7 @@
           </a:fontRef>
         </p:style>
         <p:txBody>
-          <a:bodyPr rtlCol="0" anchor="ctr" wrap="square" lIns="73152" rIns="73152" tIns="36576" bIns="36576"/>
+          <a:bodyPr wrap="square" lIns="73152" tIns="36576" rIns="73152" bIns="36576" rtlCol="0" anchor="ctr"/>
           <a:lstStyle/>
           <a:p>
             <a:pPr algn="ctr"/>
@@ -20010,7 +20319,7 @@
       <p:sp>
         <p:nvSpPr>
           <p:cNvPr id="13" name="Rounded Rectangle 12">
-            <a:hlinkClick action="ppaction://hlinksldjump" r:id="rId10"/>
+            <a:hlinkClick r:id="rId10" action="ppaction://hlinksldjump"/>
           </p:cNvPr>
           <p:cNvSpPr/>
           <p:nvPr/>
@@ -20045,7 +20354,7 @@
           </a:fontRef>
         </p:style>
         <p:txBody>
-          <a:bodyPr rtlCol="0" anchor="ctr" wrap="square" lIns="73152" rIns="73152" tIns="36576" bIns="36576"/>
+          <a:bodyPr wrap="square" lIns="73152" tIns="36576" rIns="73152" bIns="36576" rtlCol="0" anchor="ctr"/>
           <a:lstStyle/>
           <a:p>
             <a:pPr algn="ctr"/>
@@ -20103,6 +20412,7 @@
           <a:lstStyle/>
           <a:p>
             <a:pPr algn="ctr"/>
+            <a:endParaRPr/>
           </a:p>
         </p:txBody>
       </p:sp>
@@ -20196,6 +20506,7 @@
           <a:lstStyle/>
           <a:p>
             <a:pPr algn="ctr"/>
+            <a:endParaRPr/>
           </a:p>
         </p:txBody>
       </p:sp>
@@ -20271,7 +20582,7 @@
       <p:sp>
         <p:nvSpPr>
           <p:cNvPr id="20" name="Rounded Rectangle 19">
-            <a:hlinkClick action="ppaction://hlinksldjump" r:id="rId13"/>
+            <a:hlinkClick r:id="rId13" action="ppaction://hlinksldjump"/>
           </p:cNvPr>
           <p:cNvSpPr/>
           <p:nvPr/>
@@ -20308,7 +20619,7 @@
           </a:fontRef>
         </p:style>
         <p:txBody>
-          <a:bodyPr rtlCol="0" anchor="ctr" wrap="square" lIns="73152" rIns="73152" tIns="36576" bIns="36576"/>
+          <a:bodyPr wrap="square" lIns="73152" tIns="36576" rIns="73152" bIns="36576" rtlCol="0" anchor="ctr"/>
           <a:lstStyle/>
           <a:p>
             <a:pPr algn="ctr"/>
@@ -20327,7 +20638,7 @@
       <p:sp>
         <p:nvSpPr>
           <p:cNvPr id="21" name="Rounded Rectangle 20">
-            <a:hlinkClick action="ppaction://hlinksldjump" r:id="rId14"/>
+            <a:hlinkClick r:id="rId14" action="ppaction://hlinksldjump"/>
           </p:cNvPr>
           <p:cNvSpPr/>
           <p:nvPr/>
@@ -20362,7 +20673,7 @@
           </a:fontRef>
         </p:style>
         <p:txBody>
-          <a:bodyPr rtlCol="0" anchor="ctr" wrap="square" lIns="73152" rIns="73152" tIns="36576" bIns="36576"/>
+          <a:bodyPr wrap="square" lIns="73152" tIns="36576" rIns="73152" bIns="36576" rtlCol="0" anchor="ctr"/>
           <a:lstStyle/>
           <a:p>
             <a:pPr algn="ctr"/>
@@ -20420,6 +20731,7 @@
           <a:lstStyle/>
           <a:p>
             <a:pPr algn="ctr"/>
+            <a:endParaRPr/>
           </a:p>
         </p:txBody>
       </p:sp>
@@ -20511,6 +20823,7 @@
           <a:lstStyle/>
           <a:p>
             <a:pPr algn="ctr"/>
+            <a:endParaRPr/>
           </a:p>
         </p:txBody>
       </p:sp>
@@ -20602,6 +20915,7 @@
           <a:lstStyle/>
           <a:p>
             <a:pPr algn="ctr"/>
+            <a:endParaRPr/>
           </a:p>
         </p:txBody>
       </p:sp>
@@ -20693,6 +21007,7 @@
           <a:lstStyle/>
           <a:p>
             <a:pPr algn="ctr"/>
+            <a:endParaRPr/>
           </a:p>
         </p:txBody>
       </p:sp>
@@ -20784,6 +21099,7 @@
           <a:lstStyle/>
           <a:p>
             <a:pPr algn="ctr"/>
+            <a:endParaRPr/>
           </a:p>
         </p:txBody>
       </p:sp>
@@ -20895,6 +21211,7 @@
           <a:lstStyle/>
           <a:p>
             <a:pPr algn="ctr"/>
+            <a:endParaRPr/>
           </a:p>
         </p:txBody>
       </p:sp>
@@ -20938,6 +21255,7 @@
           <a:lstStyle/>
           <a:p>
             <a:pPr algn="ctr"/>
+            <a:endParaRPr/>
           </a:p>
         </p:txBody>
       </p:sp>
@@ -21015,6 +21333,7 @@
           <a:lstStyle/>
           <a:p>
             <a:pPr algn="ctr"/>
+            <a:endParaRPr/>
           </a:p>
         </p:txBody>
       </p:sp>
@@ -21058,6 +21377,7 @@
           <a:lstStyle/>
           <a:p>
             <a:pPr algn="ctr"/>
+            <a:endParaRPr/>
           </a:p>
         </p:txBody>
       </p:sp>
@@ -21135,6 +21455,7 @@
           <a:lstStyle/>
           <a:p>
             <a:pPr algn="ctr"/>
+            <a:endParaRPr/>
           </a:p>
         </p:txBody>
       </p:sp>
@@ -21178,6 +21499,7 @@
           <a:lstStyle/>
           <a:p>
             <a:pPr algn="ctr"/>
+            <a:endParaRPr/>
           </a:p>
         </p:txBody>
       </p:sp>
@@ -21255,6 +21577,7 @@
           <a:lstStyle/>
           <a:p>
             <a:pPr algn="ctr"/>
+            <a:endParaRPr/>
           </a:p>
         </p:txBody>
       </p:sp>
@@ -21298,6 +21621,7 @@
           <a:lstStyle/>
           <a:p>
             <a:pPr algn="ctr"/>
+            <a:endParaRPr/>
           </a:p>
         </p:txBody>
       </p:sp>
@@ -21343,6 +21667,7 @@
           <a:lstStyle/>
           <a:p>
             <a:pPr algn="ctr"/>
+            <a:endParaRPr/>
           </a:p>
         </p:txBody>
       </p:sp>
@@ -21422,6 +21747,7 @@
           <a:lstStyle/>
           <a:p>
             <a:pPr algn="ctr"/>
+            <a:endParaRPr/>
           </a:p>
         </p:txBody>
       </p:sp>
@@ -21520,6 +21846,7 @@
           <a:lstStyle/>
           <a:p>
             <a:pPr algn="ctr"/>
+            <a:endParaRPr/>
           </a:p>
         </p:txBody>
       </p:sp>
@@ -21618,6 +21945,7 @@
           <a:lstStyle/>
           <a:p>
             <a:pPr algn="ctr"/>
+            <a:endParaRPr/>
           </a:p>
         </p:txBody>
       </p:sp>
@@ -21716,6 +22044,7 @@
           <a:lstStyle/>
           <a:p>
             <a:pPr algn="ctr"/>
+            <a:endParaRPr/>
           </a:p>
         </p:txBody>
       </p:sp>
@@ -21775,7 +22104,7 @@
       <p:sp>
         <p:nvSpPr>
           <p:cNvPr id="54" name="Rounded Rectangle 53">
-            <a:hlinkClick action="ppaction://hlinksldjump" r:id="rId14"/>
+            <a:hlinkClick r:id="rId14" action="ppaction://hlinksldjump"/>
           </p:cNvPr>
           <p:cNvSpPr/>
           <p:nvPr/>
@@ -21810,7 +22139,7 @@
           </a:fontRef>
         </p:style>
         <p:txBody>
-          <a:bodyPr rtlCol="0" anchor="ctr" wrap="square" lIns="73152" rIns="73152" tIns="36576" bIns="36576"/>
+          <a:bodyPr wrap="square" lIns="73152" tIns="36576" rIns="73152" bIns="36576" rtlCol="0" anchor="ctr"/>
           <a:lstStyle/>
           <a:p>
             <a:pPr algn="ctr"/>
@@ -21835,7 +22164,7 @@
 </file>
 
 <file path=ppt/slides/slide9.xml><?xml version="1.0" encoding="utf-8"?>
-<p:sld xmlns:a="http://schemas.openxmlformats.org/drawingml/2006/main" xmlns:p="http://schemas.openxmlformats.org/presentationml/2006/main" xmlns:r="http://schemas.openxmlformats.org/officeDocument/2006/relationships">
+<p:sld xmlns:a="http://schemas.openxmlformats.org/drawingml/2006/main" xmlns:r="http://schemas.openxmlformats.org/officeDocument/2006/relationships" xmlns:p="http://schemas.openxmlformats.org/presentationml/2006/main">
   <p:cSld>
     <p:spTree>
       <p:nvGrpSpPr>
@@ -21843,7 +22172,14 @@
         <p:cNvGrpSpPr/>
         <p:nvPr/>
       </p:nvGrpSpPr>
-      <p:grpSpPr/>
+      <p:grpSpPr>
+        <a:xfrm>
+          <a:off x="0" y="0"/>
+          <a:ext cx="0" cy="0"/>
+          <a:chOff x="0" y="0"/>
+          <a:chExt cx="0" cy="0"/>
+        </a:xfrm>
+      </p:grpSpPr>
       <p:sp>
         <p:nvSpPr>
           <p:cNvPr id="2" name="Rectangle 1"/>
@@ -21884,6 +22220,7 @@
           <a:lstStyle/>
           <a:p>
             <a:pPr algn="ctr"/>
+            <a:endParaRPr/>
           </a:p>
         </p:txBody>
       </p:sp>
@@ -21953,6 +22290,7 @@
           <a:lstStyle/>
           <a:p>
             <a:pPr algn="ctr"/>
+            <a:endParaRPr/>
           </a:p>
         </p:txBody>
       </p:sp>
@@ -22003,7 +22341,7 @@
           <a:lstStyle/>
           <a:p>
             <a:r>
-              <a:rPr b="1" sz="1300">
+              <a:rPr sz="1300" b="1">
                 <a:solidFill>
                   <a:srgbClr val="4F46E5"/>
                 </a:solidFill>
@@ -22012,7 +22350,7 @@
               <a:t>CompliScan </a:t>
             </a:r>
             <a:r>
-              <a:rPr b="1" sz="1300">
+              <a:rPr sz="1300" b="1">
                 <a:solidFill>
                   <a:srgbClr val="10B981"/>
                 </a:solidFill>
@@ -22037,7 +22375,7 @@
       <p:sp>
         <p:nvSpPr>
           <p:cNvPr id="7" name="Rounded Rectangle 6">
-            <a:hlinkClick action="ppaction://hlinksldjump" r:id="rId4"/>
+            <a:hlinkClick r:id="rId4" action="ppaction://hlinksldjump"/>
           </p:cNvPr>
           <p:cNvSpPr/>
           <p:nvPr/>
@@ -22072,7 +22410,7 @@
           </a:fontRef>
         </p:style>
         <p:txBody>
-          <a:bodyPr rtlCol="0" anchor="ctr" wrap="square" lIns="73152" rIns="73152" tIns="36576" bIns="36576"/>
+          <a:bodyPr wrap="square" lIns="73152" tIns="36576" rIns="73152" bIns="36576" rtlCol="0" anchor="ctr"/>
           <a:lstStyle/>
           <a:p>
             <a:pPr algn="ctr"/>
@@ -22091,7 +22429,7 @@
       <p:sp>
         <p:nvSpPr>
           <p:cNvPr id="8" name="Rounded Rectangle 7">
-            <a:hlinkClick action="ppaction://hlinksldjump" r:id="rId5"/>
+            <a:hlinkClick r:id="rId5" action="ppaction://hlinksldjump"/>
           </p:cNvPr>
           <p:cNvSpPr/>
           <p:nvPr/>
@@ -22126,7 +22464,7 @@
           </a:fontRef>
         </p:style>
         <p:txBody>
-          <a:bodyPr rtlCol="0" anchor="ctr" wrap="square" lIns="73152" rIns="73152" tIns="36576" bIns="36576"/>
+          <a:bodyPr wrap="square" lIns="73152" tIns="36576" rIns="73152" bIns="36576" rtlCol="0" anchor="ctr"/>
           <a:lstStyle/>
           <a:p>
             <a:pPr algn="ctr"/>
@@ -22145,7 +22483,7 @@
       <p:sp>
         <p:nvSpPr>
           <p:cNvPr id="9" name="Rounded Rectangle 8">
-            <a:hlinkClick action="ppaction://hlinksldjump" r:id="rId6"/>
+            <a:hlinkClick r:id="rId6" action="ppaction://hlinksldjump"/>
           </p:cNvPr>
           <p:cNvSpPr/>
           <p:nvPr/>
@@ -22180,7 +22518,7 @@
           </a:fontRef>
         </p:style>
         <p:txBody>
-          <a:bodyPr rtlCol="0" anchor="ctr" wrap="square" lIns="73152" rIns="73152" tIns="36576" bIns="36576"/>
+          <a:bodyPr wrap="square" lIns="73152" tIns="36576" rIns="73152" bIns="36576" rtlCol="0" anchor="ctr"/>
           <a:lstStyle/>
           <a:p>
             <a:pPr algn="ctr"/>
@@ -22199,7 +22537,7 @@
       <p:sp>
         <p:nvSpPr>
           <p:cNvPr id="10" name="Rounded Rectangle 9">
-            <a:hlinkClick action="ppaction://hlinksldjump" r:id="rId7"/>
+            <a:hlinkClick r:id="rId7" action="ppaction://hlinksldjump"/>
           </p:cNvPr>
           <p:cNvSpPr/>
           <p:nvPr/>
@@ -22234,7 +22572,7 @@
           </a:fontRef>
         </p:style>
         <p:txBody>
-          <a:bodyPr rtlCol="0" anchor="ctr" wrap="square" lIns="73152" rIns="73152" tIns="36576" bIns="36576"/>
+          <a:bodyPr wrap="square" lIns="73152" tIns="36576" rIns="73152" bIns="36576" rtlCol="0" anchor="ctr"/>
           <a:lstStyle/>
           <a:p>
             <a:pPr algn="ctr"/>
@@ -22253,7 +22591,7 @@
       <p:sp>
         <p:nvSpPr>
           <p:cNvPr id="11" name="Rounded Rectangle 10">
-            <a:hlinkClick action="ppaction://hlinksldjump" r:id="rId8"/>
+            <a:hlinkClick r:id="rId8" action="ppaction://hlinksldjump"/>
           </p:cNvPr>
           <p:cNvSpPr/>
           <p:nvPr/>
@@ -22288,7 +22626,7 @@
           </a:fontRef>
         </p:style>
         <p:txBody>
-          <a:bodyPr rtlCol="0" anchor="ctr" wrap="square" lIns="73152" rIns="73152" tIns="36576" bIns="36576"/>
+          <a:bodyPr wrap="square" lIns="73152" tIns="36576" rIns="73152" bIns="36576" rtlCol="0" anchor="ctr"/>
           <a:lstStyle/>
           <a:p>
             <a:pPr algn="ctr"/>
@@ -22307,7 +22645,7 @@
       <p:sp>
         <p:nvSpPr>
           <p:cNvPr id="12" name="Rounded Rectangle 11">
-            <a:hlinkClick action="ppaction://hlinksldjump" r:id="rId9"/>
+            <a:hlinkClick r:id="rId9" action="ppaction://hlinksldjump"/>
           </p:cNvPr>
           <p:cNvSpPr/>
           <p:nvPr/>
@@ -22342,7 +22680,7 @@
           </a:fontRef>
         </p:style>
         <p:txBody>
-          <a:bodyPr rtlCol="0" anchor="ctr" wrap="square" lIns="73152" rIns="73152" tIns="36576" bIns="36576"/>
+          <a:bodyPr wrap="square" lIns="73152" tIns="36576" rIns="73152" bIns="36576" rtlCol="0" anchor="ctr"/>
           <a:lstStyle/>
           <a:p>
             <a:pPr algn="ctr"/>
@@ -22361,7 +22699,7 @@
       <p:sp>
         <p:nvSpPr>
           <p:cNvPr id="13" name="Rounded Rectangle 12">
-            <a:hlinkClick action="ppaction://hlinksldjump" r:id="rId10"/>
+            <a:hlinkClick r:id="rId10" action="ppaction://hlinksldjump"/>
           </p:cNvPr>
           <p:cNvSpPr/>
           <p:nvPr/>
@@ -22396,7 +22734,7 @@
           </a:fontRef>
         </p:style>
         <p:txBody>
-          <a:bodyPr rtlCol="0" anchor="ctr" wrap="square" lIns="73152" rIns="73152" tIns="36576" bIns="36576"/>
+          <a:bodyPr wrap="square" lIns="73152" tIns="36576" rIns="73152" bIns="36576" rtlCol="0" anchor="ctr"/>
           <a:lstStyle/>
           <a:p>
             <a:pPr algn="ctr"/>
@@ -22454,6 +22792,7 @@
           <a:lstStyle/>
           <a:p>
             <a:pPr algn="ctr"/>
+            <a:endParaRPr/>
           </a:p>
         </p:txBody>
       </p:sp>
@@ -22547,6 +22886,7 @@
           <a:lstStyle/>
           <a:p>
             <a:pPr algn="ctr"/>
+            <a:endParaRPr/>
           </a:p>
         </p:txBody>
       </p:sp>
@@ -22622,7 +22962,7 @@
       <p:sp>
         <p:nvSpPr>
           <p:cNvPr id="20" name="Rounded Rectangle 19">
-            <a:hlinkClick action="ppaction://hlinksldjump" r:id="rId9"/>
+            <a:hlinkClick r:id="rId9" action="ppaction://hlinksldjump"/>
           </p:cNvPr>
           <p:cNvSpPr/>
           <p:nvPr/>
@@ -22659,7 +22999,7 @@
           </a:fontRef>
         </p:style>
         <p:txBody>
-          <a:bodyPr rtlCol="0" anchor="ctr" wrap="square" lIns="73152" rIns="73152" tIns="36576" bIns="36576"/>
+          <a:bodyPr wrap="square" lIns="73152" tIns="36576" rIns="73152" bIns="36576" rtlCol="0" anchor="ctr"/>
           <a:lstStyle/>
           <a:p>
             <a:pPr algn="ctr"/>
@@ -22678,7 +23018,7 @@
       <p:sp>
         <p:nvSpPr>
           <p:cNvPr id="21" name="Rounded Rectangle 20">
-            <a:hlinkClick action="ppaction://hlinksldjump" r:id="rId10"/>
+            <a:hlinkClick r:id="rId10" action="ppaction://hlinksldjump"/>
           </p:cNvPr>
           <p:cNvSpPr/>
           <p:nvPr/>
@@ -22713,7 +23053,7 @@
           </a:fontRef>
         </p:style>
         <p:txBody>
-          <a:bodyPr rtlCol="0" anchor="ctr" wrap="square" lIns="73152" rIns="73152" tIns="36576" bIns="36576"/>
+          <a:bodyPr wrap="square" lIns="73152" tIns="36576" rIns="73152" bIns="36576" rtlCol="0" anchor="ctr"/>
           <a:lstStyle/>
           <a:p>
             <a:pPr algn="ctr"/>
@@ -22771,6 +23111,7 @@
           <a:lstStyle/>
           <a:p>
             <a:pPr algn="ctr"/>
+            <a:endParaRPr/>
           </a:p>
         </p:txBody>
       </p:sp>
@@ -22816,6 +23157,7 @@
           <a:lstStyle/>
           <a:p>
             <a:pPr algn="ctr"/>
+            <a:endParaRPr/>
           </a:p>
         </p:txBody>
       </p:sp>
@@ -22895,6 +23237,7 @@
           <a:lstStyle/>
           <a:p>
             <a:pPr algn="ctr"/>
+            <a:endParaRPr/>
           </a:p>
         </p:txBody>
       </p:sp>
@@ -22986,6 +23329,7 @@
           <a:lstStyle/>
           <a:p>
             <a:pPr algn="ctr"/>
+            <a:endParaRPr/>
           </a:p>
         </p:txBody>
       </p:sp>
@@ -23077,6 +23421,7 @@
           <a:lstStyle/>
           <a:p>
             <a:pPr algn="ctr"/>
+            <a:endParaRPr/>
           </a:p>
         </p:txBody>
       </p:sp>
@@ -23168,6 +23513,7 @@
           <a:lstStyle/>
           <a:p>
             <a:pPr algn="ctr"/>
+            <a:endParaRPr/>
           </a:p>
         </p:txBody>
       </p:sp>
@@ -23259,6 +23605,7 @@
           <a:lstStyle/>
           <a:p>
             <a:pPr algn="ctr"/>
+            <a:endParaRPr/>
           </a:p>
         </p:txBody>
       </p:sp>
@@ -23304,6 +23651,7 @@
           <a:lstStyle/>
           <a:p>
             <a:pPr algn="ctr"/>
+            <a:endParaRPr/>
           </a:p>
         </p:txBody>
       </p:sp>
@@ -23383,6 +23731,7 @@
           <a:lstStyle/>
           <a:p>
             <a:pPr algn="ctr"/>
+            <a:endParaRPr/>
           </a:p>
         </p:txBody>
       </p:sp>
@@ -23474,6 +23823,7 @@
           <a:lstStyle/>
           <a:p>
             <a:pPr algn="ctr"/>
+            <a:endParaRPr/>
           </a:p>
         </p:txBody>
       </p:sp>
@@ -23565,6 +23915,7 @@
           <a:lstStyle/>
           <a:p>
             <a:pPr algn="ctr"/>
+            <a:endParaRPr/>
           </a:p>
         </p:txBody>
       </p:sp>
@@ -23656,6 +24007,7 @@
           <a:lstStyle/>
           <a:p>
             <a:pPr algn="ctr"/>
+            <a:endParaRPr/>
           </a:p>
         </p:txBody>
       </p:sp>
@@ -23708,7 +24060,7 @@
       <p:sp>
         <p:nvSpPr>
           <p:cNvPr id="44" name="Rounded Rectangle 43">
-            <a:hlinkClick action="ppaction://hlinksldjump" r:id="rId10"/>
+            <a:hlinkClick r:id="rId10" action="ppaction://hlinksldjump"/>
           </p:cNvPr>
           <p:cNvSpPr/>
           <p:nvPr/>
@@ -23743,7 +24095,7 @@
           </a:fontRef>
         </p:style>
         <p:txBody>
-          <a:bodyPr rtlCol="0" anchor="ctr" wrap="square" lIns="73152" rIns="73152" tIns="36576" bIns="36576"/>
+          <a:bodyPr wrap="square" lIns="73152" tIns="36576" rIns="73152" bIns="36576" rtlCol="0" anchor="ctr"/>
           <a:lstStyle/>
           <a:p>
             <a:pPr algn="ctr"/>

</xml_diff>